<commit_message>
ötlet infók meglettek adva
</commit_message>
<xml_diff>
--- a/Dokumentumok/cím.pptx
+++ b/Dokumentumok/cím.pptx
@@ -2,7 +2,7 @@
 <file path=ppt/presentation.xml><?xml version="1.0" encoding="utf-8"?>
 <p:presentation xmlns:a="http://schemas.openxmlformats.org/drawingml/2006/main" xmlns:r="http://schemas.openxmlformats.org/officeDocument/2006/relationships" xmlns:p="http://schemas.openxmlformats.org/presentationml/2006/main" saveSubsetFonts="1">
   <p:sldMasterIdLst>
-    <p:sldMasterId id="2147483648" r:id="rId1"/>
+    <p:sldMasterId id="2147483677" r:id="rId1"/>
   </p:sldMasterIdLst>
   <p:sldIdLst>
     <p:sldId id="256" r:id="rId2"/>
@@ -105,6 +105,11 @@
       </a:defRPr>
     </a:lvl9pPr>
   </p:defaultTextStyle>
+  <p:extLst>
+    <p:ext uri="{EFAFB233-063F-42B5-8137-9DF3F51BA10A}">
+      <p15:sldGuideLst xmlns:p15="http://schemas.microsoft.com/office/powerpoint/2012/main"/>
+    </p:ext>
+  </p:extLst>
 </p:presentation>
 </file>
 
@@ -130,7 +135,7 @@
           <p:cNvPr id="2" name="Cím 1">
             <a:extLst>
               <a:ext uri="{FF2B5EF4-FFF2-40B4-BE49-F238E27FC236}">
-                <a16:creationId xmlns:a16="http://schemas.microsoft.com/office/drawing/2014/main" id="{8624BC43-D9B7-47B1-A5F2-D65157659BDE}"/>
+                <a16:creationId xmlns:a16="http://schemas.microsoft.com/office/drawing/2014/main" id="{D994EB61-F3A1-4EAB-9FE9-C2BAA0BA08A9}"/>
               </a:ext>
             </a:extLst>
           </p:cNvPr>
@@ -167,7 +172,7 @@
           <p:cNvPr id="3" name="Alcím 2">
             <a:extLst>
               <a:ext uri="{FF2B5EF4-FFF2-40B4-BE49-F238E27FC236}">
-                <a16:creationId xmlns:a16="http://schemas.microsoft.com/office/drawing/2014/main" id="{AB958DF1-4F40-4CBD-A7A2-0BB9A7E185D8}"/>
+                <a16:creationId xmlns:a16="http://schemas.microsoft.com/office/drawing/2014/main" id="{C61812BB-D2C3-491F-A97E-28B542473C5E}"/>
               </a:ext>
             </a:extLst>
           </p:cNvPr>
@@ -237,7 +242,7 @@
           <p:cNvPr id="4" name="Dátum helye 3">
             <a:extLst>
               <a:ext uri="{FF2B5EF4-FFF2-40B4-BE49-F238E27FC236}">
-                <a16:creationId xmlns:a16="http://schemas.microsoft.com/office/drawing/2014/main" id="{C1BDB11F-D40F-4637-BDFA-549874D809CF}"/>
+                <a16:creationId xmlns:a16="http://schemas.microsoft.com/office/drawing/2014/main" id="{DB9FB2F1-E4BE-4B2B-A8C8-55E7FA5F4DD0}"/>
               </a:ext>
             </a:extLst>
           </p:cNvPr>
@@ -255,7 +260,7 @@
           <a:p>
             <a:fld id="{B9A16147-4286-4EA3-A7A6-0076531D1571}" type="datetimeFigureOut">
               <a:rPr lang="hu-HU" smtClean="0"/>
-              <a:t>2026.03.23.</a:t>
+              <a:t>2026.03.24.</a:t>
             </a:fld>
             <a:endParaRPr lang="hu-HU"/>
           </a:p>
@@ -266,7 +271,7 @@
           <p:cNvPr id="5" name="Élőláb helye 4">
             <a:extLst>
               <a:ext uri="{FF2B5EF4-FFF2-40B4-BE49-F238E27FC236}">
-                <a16:creationId xmlns:a16="http://schemas.microsoft.com/office/drawing/2014/main" id="{45563D29-DAB2-4235-8220-362885F659DB}"/>
+                <a16:creationId xmlns:a16="http://schemas.microsoft.com/office/drawing/2014/main" id="{2DBEACA8-32FF-47CB-B61C-5788C5CA2DEE}"/>
               </a:ext>
             </a:extLst>
           </p:cNvPr>
@@ -291,7 +296,7 @@
           <p:cNvPr id="6" name="Dia számának helye 5">
             <a:extLst>
               <a:ext uri="{FF2B5EF4-FFF2-40B4-BE49-F238E27FC236}">
-                <a16:creationId xmlns:a16="http://schemas.microsoft.com/office/drawing/2014/main" id="{BE441F74-D055-4856-A9C0-2DC3E779F73C}"/>
+                <a16:creationId xmlns:a16="http://schemas.microsoft.com/office/drawing/2014/main" id="{8963897E-1798-4D59-8DBE-817FE9575600}"/>
               </a:ext>
             </a:extLst>
           </p:cNvPr>
@@ -318,7 +323,7 @@
     </p:spTree>
     <p:extLst>
       <p:ext uri="{BB962C8B-B14F-4D97-AF65-F5344CB8AC3E}">
-        <p14:creationId xmlns:p14="http://schemas.microsoft.com/office/powerpoint/2010/main" val="2579964286"/>
+        <p14:creationId xmlns:p14="http://schemas.microsoft.com/office/powerpoint/2010/main" val="1917273584"/>
       </p:ext>
     </p:extLst>
   </p:cSld>
@@ -350,7 +355,7 @@
           <p:cNvPr id="2" name="Cím 1">
             <a:extLst>
               <a:ext uri="{FF2B5EF4-FFF2-40B4-BE49-F238E27FC236}">
-                <a16:creationId xmlns:a16="http://schemas.microsoft.com/office/drawing/2014/main" id="{07EE94C6-9527-46D5-A819-5A21E07C5C67}"/>
+                <a16:creationId xmlns:a16="http://schemas.microsoft.com/office/drawing/2014/main" id="{B103DA8E-C17D-4C42-B0F4-B81038EA7634}"/>
               </a:ext>
             </a:extLst>
           </p:cNvPr>
@@ -378,7 +383,7 @@
           <p:cNvPr id="3" name="Függőleges szöveg helye 2">
             <a:extLst>
               <a:ext uri="{FF2B5EF4-FFF2-40B4-BE49-F238E27FC236}">
-                <a16:creationId xmlns:a16="http://schemas.microsoft.com/office/drawing/2014/main" id="{C7F80123-A5C8-42B9-95D3-5C6F0827D83D}"/>
+                <a16:creationId xmlns:a16="http://schemas.microsoft.com/office/drawing/2014/main" id="{0ED737BC-49F6-4023-89C9-B9EDFE2A97CB}"/>
               </a:ext>
             </a:extLst>
           </p:cNvPr>
@@ -435,7 +440,7 @@
           <p:cNvPr id="4" name="Dátum helye 3">
             <a:extLst>
               <a:ext uri="{FF2B5EF4-FFF2-40B4-BE49-F238E27FC236}">
-                <a16:creationId xmlns:a16="http://schemas.microsoft.com/office/drawing/2014/main" id="{E9754CAA-6705-474A-8126-CC58A1359DE6}"/>
+                <a16:creationId xmlns:a16="http://schemas.microsoft.com/office/drawing/2014/main" id="{D9DADC01-63D0-4F32-8AFC-698EC766DCED}"/>
               </a:ext>
             </a:extLst>
           </p:cNvPr>
@@ -453,7 +458,7 @@
           <a:p>
             <a:fld id="{B9A16147-4286-4EA3-A7A6-0076531D1571}" type="datetimeFigureOut">
               <a:rPr lang="hu-HU" smtClean="0"/>
-              <a:t>2026.03.23.</a:t>
+              <a:t>2026.03.24.</a:t>
             </a:fld>
             <a:endParaRPr lang="hu-HU"/>
           </a:p>
@@ -464,7 +469,7 @@
           <p:cNvPr id="5" name="Élőláb helye 4">
             <a:extLst>
               <a:ext uri="{FF2B5EF4-FFF2-40B4-BE49-F238E27FC236}">
-                <a16:creationId xmlns:a16="http://schemas.microsoft.com/office/drawing/2014/main" id="{AB1E14CB-65C0-4142-88E7-D8DFFF677DB2}"/>
+                <a16:creationId xmlns:a16="http://schemas.microsoft.com/office/drawing/2014/main" id="{983B4E11-BA54-4FD2-8A5F-D5F5BD26E5C9}"/>
               </a:ext>
             </a:extLst>
           </p:cNvPr>
@@ -489,7 +494,7 @@
           <p:cNvPr id="6" name="Dia számának helye 5">
             <a:extLst>
               <a:ext uri="{FF2B5EF4-FFF2-40B4-BE49-F238E27FC236}">
-                <a16:creationId xmlns:a16="http://schemas.microsoft.com/office/drawing/2014/main" id="{920135D2-4C15-4D36-AEB5-2C71D0E59B27}"/>
+                <a16:creationId xmlns:a16="http://schemas.microsoft.com/office/drawing/2014/main" id="{DA033BE7-6A49-4B39-B5B5-36534CB1B2A0}"/>
               </a:ext>
             </a:extLst>
           </p:cNvPr>
@@ -516,7 +521,7 @@
     </p:spTree>
     <p:extLst>
       <p:ext uri="{BB962C8B-B14F-4D97-AF65-F5344CB8AC3E}">
-        <p14:creationId xmlns:p14="http://schemas.microsoft.com/office/powerpoint/2010/main" val="3871184854"/>
+        <p14:creationId xmlns:p14="http://schemas.microsoft.com/office/powerpoint/2010/main" val="184581622"/>
       </p:ext>
     </p:extLst>
   </p:cSld>
@@ -548,7 +553,7 @@
           <p:cNvPr id="2" name="Függőleges cím 1">
             <a:extLst>
               <a:ext uri="{FF2B5EF4-FFF2-40B4-BE49-F238E27FC236}">
-                <a16:creationId xmlns:a16="http://schemas.microsoft.com/office/drawing/2014/main" id="{49BDEF08-E3B0-4212-BEDB-377FF90828CC}"/>
+                <a16:creationId xmlns:a16="http://schemas.microsoft.com/office/drawing/2014/main" id="{FB2A961D-AFC9-4EF4-8F35-2B3A204CD188}"/>
               </a:ext>
             </a:extLst>
           </p:cNvPr>
@@ -581,7 +586,7 @@
           <p:cNvPr id="3" name="Függőleges szöveg helye 2">
             <a:extLst>
               <a:ext uri="{FF2B5EF4-FFF2-40B4-BE49-F238E27FC236}">
-                <a16:creationId xmlns:a16="http://schemas.microsoft.com/office/drawing/2014/main" id="{F9EBF9E2-1FA0-4173-A1C0-2F4C7ED3A57B}"/>
+                <a16:creationId xmlns:a16="http://schemas.microsoft.com/office/drawing/2014/main" id="{429CD66F-4E1C-4CE4-9AFD-E6C4B9D8EA3A}"/>
               </a:ext>
             </a:extLst>
           </p:cNvPr>
@@ -643,7 +648,7 @@
           <p:cNvPr id="4" name="Dátum helye 3">
             <a:extLst>
               <a:ext uri="{FF2B5EF4-FFF2-40B4-BE49-F238E27FC236}">
-                <a16:creationId xmlns:a16="http://schemas.microsoft.com/office/drawing/2014/main" id="{5E3B341E-E40B-42C1-A650-F62D6507AB3A}"/>
+                <a16:creationId xmlns:a16="http://schemas.microsoft.com/office/drawing/2014/main" id="{C96A8E38-540E-4183-B1A6-1F53E5D4AEB0}"/>
               </a:ext>
             </a:extLst>
           </p:cNvPr>
@@ -661,7 +666,7 @@
           <a:p>
             <a:fld id="{B9A16147-4286-4EA3-A7A6-0076531D1571}" type="datetimeFigureOut">
               <a:rPr lang="hu-HU" smtClean="0"/>
-              <a:t>2026.03.23.</a:t>
+              <a:t>2026.03.24.</a:t>
             </a:fld>
             <a:endParaRPr lang="hu-HU"/>
           </a:p>
@@ -672,7 +677,7 @@
           <p:cNvPr id="5" name="Élőláb helye 4">
             <a:extLst>
               <a:ext uri="{FF2B5EF4-FFF2-40B4-BE49-F238E27FC236}">
-                <a16:creationId xmlns:a16="http://schemas.microsoft.com/office/drawing/2014/main" id="{F8FAFA0C-E28D-4C42-808E-439EBE7E87ED}"/>
+                <a16:creationId xmlns:a16="http://schemas.microsoft.com/office/drawing/2014/main" id="{48353271-FF9C-4E16-91C8-FFAB4D819A81}"/>
               </a:ext>
             </a:extLst>
           </p:cNvPr>
@@ -697,7 +702,7 @@
           <p:cNvPr id="6" name="Dia számának helye 5">
             <a:extLst>
               <a:ext uri="{FF2B5EF4-FFF2-40B4-BE49-F238E27FC236}">
-                <a16:creationId xmlns:a16="http://schemas.microsoft.com/office/drawing/2014/main" id="{25A2B361-33C3-4F27-A7CD-63ADE9C13619}"/>
+                <a16:creationId xmlns:a16="http://schemas.microsoft.com/office/drawing/2014/main" id="{5F181CD7-6F94-4758-8DF4-76D5D54C3EC2}"/>
               </a:ext>
             </a:extLst>
           </p:cNvPr>
@@ -724,7 +729,7 @@
     </p:spTree>
     <p:extLst>
       <p:ext uri="{BB962C8B-B14F-4D97-AF65-F5344CB8AC3E}">
-        <p14:creationId xmlns:p14="http://schemas.microsoft.com/office/powerpoint/2010/main" val="3316983875"/>
+        <p14:creationId xmlns:p14="http://schemas.microsoft.com/office/powerpoint/2010/main" val="3082856890"/>
       </p:ext>
     </p:extLst>
   </p:cSld>
@@ -756,7 +761,7 @@
           <p:cNvPr id="2" name="Cím 1">
             <a:extLst>
               <a:ext uri="{FF2B5EF4-FFF2-40B4-BE49-F238E27FC236}">
-                <a16:creationId xmlns:a16="http://schemas.microsoft.com/office/drawing/2014/main" id="{499E7501-B923-405B-9347-CD2E4CD4E50B}"/>
+                <a16:creationId xmlns:a16="http://schemas.microsoft.com/office/drawing/2014/main" id="{A34CB0DA-74EB-45DF-80F9-812DDFB5B6E6}"/>
               </a:ext>
             </a:extLst>
           </p:cNvPr>
@@ -784,7 +789,7 @@
           <p:cNvPr id="3" name="Tartalom helye 2">
             <a:extLst>
               <a:ext uri="{FF2B5EF4-FFF2-40B4-BE49-F238E27FC236}">
-                <a16:creationId xmlns:a16="http://schemas.microsoft.com/office/drawing/2014/main" id="{3A544F37-E238-482C-9497-254CE43027C4}"/>
+                <a16:creationId xmlns:a16="http://schemas.microsoft.com/office/drawing/2014/main" id="{78541346-7FC8-4157-B791-BDA6DD1305A8}"/>
               </a:ext>
             </a:extLst>
           </p:cNvPr>
@@ -841,7 +846,7 @@
           <p:cNvPr id="4" name="Dátum helye 3">
             <a:extLst>
               <a:ext uri="{FF2B5EF4-FFF2-40B4-BE49-F238E27FC236}">
-                <a16:creationId xmlns:a16="http://schemas.microsoft.com/office/drawing/2014/main" id="{9DD2E20D-39DC-4056-8027-F475FE1CEC2B}"/>
+                <a16:creationId xmlns:a16="http://schemas.microsoft.com/office/drawing/2014/main" id="{D473A7A8-D937-4559-BB37-663A2D6FAB45}"/>
               </a:ext>
             </a:extLst>
           </p:cNvPr>
@@ -859,7 +864,7 @@
           <a:p>
             <a:fld id="{B9A16147-4286-4EA3-A7A6-0076531D1571}" type="datetimeFigureOut">
               <a:rPr lang="hu-HU" smtClean="0"/>
-              <a:t>2026.03.23.</a:t>
+              <a:t>2026.03.24.</a:t>
             </a:fld>
             <a:endParaRPr lang="hu-HU"/>
           </a:p>
@@ -870,7 +875,7 @@
           <p:cNvPr id="5" name="Élőláb helye 4">
             <a:extLst>
               <a:ext uri="{FF2B5EF4-FFF2-40B4-BE49-F238E27FC236}">
-                <a16:creationId xmlns:a16="http://schemas.microsoft.com/office/drawing/2014/main" id="{0D25BC3B-1E92-4998-AA5F-3B9BB6CAB660}"/>
+                <a16:creationId xmlns:a16="http://schemas.microsoft.com/office/drawing/2014/main" id="{11774F90-E69A-4FFF-9782-E416969F47AD}"/>
               </a:ext>
             </a:extLst>
           </p:cNvPr>
@@ -895,7 +900,7 @@
           <p:cNvPr id="6" name="Dia számának helye 5">
             <a:extLst>
               <a:ext uri="{FF2B5EF4-FFF2-40B4-BE49-F238E27FC236}">
-                <a16:creationId xmlns:a16="http://schemas.microsoft.com/office/drawing/2014/main" id="{DA54DDD0-5414-4772-9853-C0A3EC1F6B67}"/>
+                <a16:creationId xmlns:a16="http://schemas.microsoft.com/office/drawing/2014/main" id="{1FB8B2A1-3D72-4B19-88CB-6FD624A69B90}"/>
               </a:ext>
             </a:extLst>
           </p:cNvPr>
@@ -922,7 +927,7 @@
     </p:spTree>
     <p:extLst>
       <p:ext uri="{BB962C8B-B14F-4D97-AF65-F5344CB8AC3E}">
-        <p14:creationId xmlns:p14="http://schemas.microsoft.com/office/powerpoint/2010/main" val="778513459"/>
+        <p14:creationId xmlns:p14="http://schemas.microsoft.com/office/powerpoint/2010/main" val="3136633058"/>
       </p:ext>
     </p:extLst>
   </p:cSld>
@@ -954,7 +959,7 @@
           <p:cNvPr id="2" name="Cím 1">
             <a:extLst>
               <a:ext uri="{FF2B5EF4-FFF2-40B4-BE49-F238E27FC236}">
-                <a16:creationId xmlns:a16="http://schemas.microsoft.com/office/drawing/2014/main" id="{0E7FCA27-ABE7-41AE-B45E-A39F9B3AE9EC}"/>
+                <a16:creationId xmlns:a16="http://schemas.microsoft.com/office/drawing/2014/main" id="{9DEF074D-89C7-4C6D-B060-6A4125AE35A7}"/>
               </a:ext>
             </a:extLst>
           </p:cNvPr>
@@ -991,7 +996,7 @@
           <p:cNvPr id="3" name="Szöveg helye 2">
             <a:extLst>
               <a:ext uri="{FF2B5EF4-FFF2-40B4-BE49-F238E27FC236}">
-                <a16:creationId xmlns:a16="http://schemas.microsoft.com/office/drawing/2014/main" id="{BF2F1455-1146-4E7B-8E8C-B8655F31083F}"/>
+                <a16:creationId xmlns:a16="http://schemas.microsoft.com/office/drawing/2014/main" id="{72E31B5F-8161-4588-B444-E8B3321B8965}"/>
               </a:ext>
             </a:extLst>
           </p:cNvPr>
@@ -1116,7 +1121,7 @@
           <p:cNvPr id="4" name="Dátum helye 3">
             <a:extLst>
               <a:ext uri="{FF2B5EF4-FFF2-40B4-BE49-F238E27FC236}">
-                <a16:creationId xmlns:a16="http://schemas.microsoft.com/office/drawing/2014/main" id="{2E331F9D-B11B-473A-8964-433031A2A239}"/>
+                <a16:creationId xmlns:a16="http://schemas.microsoft.com/office/drawing/2014/main" id="{54189E8A-A6D9-45B7-A80C-E2D296471FD5}"/>
               </a:ext>
             </a:extLst>
           </p:cNvPr>
@@ -1134,7 +1139,7 @@
           <a:p>
             <a:fld id="{B9A16147-4286-4EA3-A7A6-0076531D1571}" type="datetimeFigureOut">
               <a:rPr lang="hu-HU" smtClean="0"/>
-              <a:t>2026.03.23.</a:t>
+              <a:t>2026.03.24.</a:t>
             </a:fld>
             <a:endParaRPr lang="hu-HU"/>
           </a:p>
@@ -1145,7 +1150,7 @@
           <p:cNvPr id="5" name="Élőláb helye 4">
             <a:extLst>
               <a:ext uri="{FF2B5EF4-FFF2-40B4-BE49-F238E27FC236}">
-                <a16:creationId xmlns:a16="http://schemas.microsoft.com/office/drawing/2014/main" id="{3188AC13-E099-4490-9FCC-74C06B784E46}"/>
+                <a16:creationId xmlns:a16="http://schemas.microsoft.com/office/drawing/2014/main" id="{9DB5030C-0F74-407C-A46D-302B9258261E}"/>
               </a:ext>
             </a:extLst>
           </p:cNvPr>
@@ -1170,7 +1175,7 @@
           <p:cNvPr id="6" name="Dia számának helye 5">
             <a:extLst>
               <a:ext uri="{FF2B5EF4-FFF2-40B4-BE49-F238E27FC236}">
-                <a16:creationId xmlns:a16="http://schemas.microsoft.com/office/drawing/2014/main" id="{53D13469-DECE-40C3-AC98-8F52AF9786F0}"/>
+                <a16:creationId xmlns:a16="http://schemas.microsoft.com/office/drawing/2014/main" id="{EAE375C4-B6EA-4BB8-9CB9-7F700F715FCE}"/>
               </a:ext>
             </a:extLst>
           </p:cNvPr>
@@ -1197,7 +1202,7 @@
     </p:spTree>
     <p:extLst>
       <p:ext uri="{BB962C8B-B14F-4D97-AF65-F5344CB8AC3E}">
-        <p14:creationId xmlns:p14="http://schemas.microsoft.com/office/powerpoint/2010/main" val="2112522996"/>
+        <p14:creationId xmlns:p14="http://schemas.microsoft.com/office/powerpoint/2010/main" val="2997327627"/>
       </p:ext>
     </p:extLst>
   </p:cSld>
@@ -1229,7 +1234,7 @@
           <p:cNvPr id="2" name="Cím 1">
             <a:extLst>
               <a:ext uri="{FF2B5EF4-FFF2-40B4-BE49-F238E27FC236}">
-                <a16:creationId xmlns:a16="http://schemas.microsoft.com/office/drawing/2014/main" id="{C72C2F23-1B0C-4718-97B2-94EF1DDDAE8A}"/>
+                <a16:creationId xmlns:a16="http://schemas.microsoft.com/office/drawing/2014/main" id="{4B9CDCF9-9E3E-4D6F-ACBB-72EA3EEE2AEC}"/>
               </a:ext>
             </a:extLst>
           </p:cNvPr>
@@ -1257,7 +1262,7 @@
           <p:cNvPr id="3" name="Tartalom helye 2">
             <a:extLst>
               <a:ext uri="{FF2B5EF4-FFF2-40B4-BE49-F238E27FC236}">
-                <a16:creationId xmlns:a16="http://schemas.microsoft.com/office/drawing/2014/main" id="{B14E61D7-6895-4327-BA02-B1E786AD5006}"/>
+                <a16:creationId xmlns:a16="http://schemas.microsoft.com/office/drawing/2014/main" id="{74AB6F8D-C321-47E0-A2EC-8A71E6DE04D3}"/>
               </a:ext>
             </a:extLst>
           </p:cNvPr>
@@ -1319,7 +1324,7 @@
           <p:cNvPr id="4" name="Tartalom helye 3">
             <a:extLst>
               <a:ext uri="{FF2B5EF4-FFF2-40B4-BE49-F238E27FC236}">
-                <a16:creationId xmlns:a16="http://schemas.microsoft.com/office/drawing/2014/main" id="{AE7BDFEB-8374-4D96-B7C1-0DC585E33AE3}"/>
+                <a16:creationId xmlns:a16="http://schemas.microsoft.com/office/drawing/2014/main" id="{30CC7F87-B5A0-462F-8F71-A5FB7595915E}"/>
               </a:ext>
             </a:extLst>
           </p:cNvPr>
@@ -1381,7 +1386,7 @@
           <p:cNvPr id="5" name="Dátum helye 4">
             <a:extLst>
               <a:ext uri="{FF2B5EF4-FFF2-40B4-BE49-F238E27FC236}">
-                <a16:creationId xmlns:a16="http://schemas.microsoft.com/office/drawing/2014/main" id="{05DF8DEB-3EFF-4E27-87A1-0744C2AB8D4C}"/>
+                <a16:creationId xmlns:a16="http://schemas.microsoft.com/office/drawing/2014/main" id="{568B5806-28B7-452C-BE09-EB96DBB29601}"/>
               </a:ext>
             </a:extLst>
           </p:cNvPr>
@@ -1399,7 +1404,7 @@
           <a:p>
             <a:fld id="{B9A16147-4286-4EA3-A7A6-0076531D1571}" type="datetimeFigureOut">
               <a:rPr lang="hu-HU" smtClean="0"/>
-              <a:t>2026.03.23.</a:t>
+              <a:t>2026.03.24.</a:t>
             </a:fld>
             <a:endParaRPr lang="hu-HU"/>
           </a:p>
@@ -1410,7 +1415,7 @@
           <p:cNvPr id="6" name="Élőláb helye 5">
             <a:extLst>
               <a:ext uri="{FF2B5EF4-FFF2-40B4-BE49-F238E27FC236}">
-                <a16:creationId xmlns:a16="http://schemas.microsoft.com/office/drawing/2014/main" id="{75EE1294-1D05-4238-82C4-F6BE45DCDC9A}"/>
+                <a16:creationId xmlns:a16="http://schemas.microsoft.com/office/drawing/2014/main" id="{3B4759FF-E7C6-4EA8-A719-248049AC120A}"/>
               </a:ext>
             </a:extLst>
           </p:cNvPr>
@@ -1435,7 +1440,7 @@
           <p:cNvPr id="7" name="Dia számának helye 6">
             <a:extLst>
               <a:ext uri="{FF2B5EF4-FFF2-40B4-BE49-F238E27FC236}">
-                <a16:creationId xmlns:a16="http://schemas.microsoft.com/office/drawing/2014/main" id="{C2F979A4-21C0-4240-BED3-F7E1399E0D6B}"/>
+                <a16:creationId xmlns:a16="http://schemas.microsoft.com/office/drawing/2014/main" id="{1968A70C-42B0-49CE-AB20-3A9E1BFEE35F}"/>
               </a:ext>
             </a:extLst>
           </p:cNvPr>
@@ -1462,7 +1467,7 @@
     </p:spTree>
     <p:extLst>
       <p:ext uri="{BB962C8B-B14F-4D97-AF65-F5344CB8AC3E}">
-        <p14:creationId xmlns:p14="http://schemas.microsoft.com/office/powerpoint/2010/main" val="2096974654"/>
+        <p14:creationId xmlns:p14="http://schemas.microsoft.com/office/powerpoint/2010/main" val="3577453429"/>
       </p:ext>
     </p:extLst>
   </p:cSld>
@@ -1494,7 +1499,7 @@
           <p:cNvPr id="2" name="Cím 1">
             <a:extLst>
               <a:ext uri="{FF2B5EF4-FFF2-40B4-BE49-F238E27FC236}">
-                <a16:creationId xmlns:a16="http://schemas.microsoft.com/office/drawing/2014/main" id="{E3787AC0-CD95-4EE3-B5C3-16E147C1E79B}"/>
+                <a16:creationId xmlns:a16="http://schemas.microsoft.com/office/drawing/2014/main" id="{94BA33BF-2146-4D46-8130-FE6417B9B06B}"/>
               </a:ext>
             </a:extLst>
           </p:cNvPr>
@@ -1527,7 +1532,7 @@
           <p:cNvPr id="3" name="Szöveg helye 2">
             <a:extLst>
               <a:ext uri="{FF2B5EF4-FFF2-40B4-BE49-F238E27FC236}">
-                <a16:creationId xmlns:a16="http://schemas.microsoft.com/office/drawing/2014/main" id="{00F93B5E-106D-4385-8BFD-AC423FD5A066}"/>
+                <a16:creationId xmlns:a16="http://schemas.microsoft.com/office/drawing/2014/main" id="{CCA7C11D-ADFF-4F1D-994D-F5821C442BDA}"/>
               </a:ext>
             </a:extLst>
           </p:cNvPr>
@@ -1598,7 +1603,7 @@
           <p:cNvPr id="4" name="Tartalom helye 3">
             <a:extLst>
               <a:ext uri="{FF2B5EF4-FFF2-40B4-BE49-F238E27FC236}">
-                <a16:creationId xmlns:a16="http://schemas.microsoft.com/office/drawing/2014/main" id="{7B86A02E-4CBC-4773-86C8-D4E33361501D}"/>
+                <a16:creationId xmlns:a16="http://schemas.microsoft.com/office/drawing/2014/main" id="{2801062C-23AC-43CC-987C-5262A38AA9BA}"/>
               </a:ext>
             </a:extLst>
           </p:cNvPr>
@@ -1660,7 +1665,7 @@
           <p:cNvPr id="5" name="Szöveg helye 4">
             <a:extLst>
               <a:ext uri="{FF2B5EF4-FFF2-40B4-BE49-F238E27FC236}">
-                <a16:creationId xmlns:a16="http://schemas.microsoft.com/office/drawing/2014/main" id="{83B728B0-88AE-4B4F-895D-3E0C31C01F93}"/>
+                <a16:creationId xmlns:a16="http://schemas.microsoft.com/office/drawing/2014/main" id="{DFD44CD3-63F2-4AEA-829F-BCE1EC6510E6}"/>
               </a:ext>
             </a:extLst>
           </p:cNvPr>
@@ -1731,7 +1736,7 @@
           <p:cNvPr id="6" name="Tartalom helye 5">
             <a:extLst>
               <a:ext uri="{FF2B5EF4-FFF2-40B4-BE49-F238E27FC236}">
-                <a16:creationId xmlns:a16="http://schemas.microsoft.com/office/drawing/2014/main" id="{DC8BD5F0-946C-42A3-A8FA-00B4BB0723FB}"/>
+                <a16:creationId xmlns:a16="http://schemas.microsoft.com/office/drawing/2014/main" id="{F9CD135A-E9A9-44DE-9316-C61B0A415E41}"/>
               </a:ext>
             </a:extLst>
           </p:cNvPr>
@@ -1793,7 +1798,7 @@
           <p:cNvPr id="7" name="Dátum helye 6">
             <a:extLst>
               <a:ext uri="{FF2B5EF4-FFF2-40B4-BE49-F238E27FC236}">
-                <a16:creationId xmlns:a16="http://schemas.microsoft.com/office/drawing/2014/main" id="{3AAF01CB-B801-404B-B97C-A78135C59CCF}"/>
+                <a16:creationId xmlns:a16="http://schemas.microsoft.com/office/drawing/2014/main" id="{BDCE332E-F869-4EF7-8032-AA179B588FF1}"/>
               </a:ext>
             </a:extLst>
           </p:cNvPr>
@@ -1811,7 +1816,7 @@
           <a:p>
             <a:fld id="{B9A16147-4286-4EA3-A7A6-0076531D1571}" type="datetimeFigureOut">
               <a:rPr lang="hu-HU" smtClean="0"/>
-              <a:t>2026.03.23.</a:t>
+              <a:t>2026.03.24.</a:t>
             </a:fld>
             <a:endParaRPr lang="hu-HU"/>
           </a:p>
@@ -1822,7 +1827,7 @@
           <p:cNvPr id="8" name="Élőláb helye 7">
             <a:extLst>
               <a:ext uri="{FF2B5EF4-FFF2-40B4-BE49-F238E27FC236}">
-                <a16:creationId xmlns:a16="http://schemas.microsoft.com/office/drawing/2014/main" id="{C7F294D6-7C75-4262-B5D1-E6DF7547BFC8}"/>
+                <a16:creationId xmlns:a16="http://schemas.microsoft.com/office/drawing/2014/main" id="{1CBD0467-2880-4902-85AA-4A9625468721}"/>
               </a:ext>
             </a:extLst>
           </p:cNvPr>
@@ -1847,7 +1852,7 @@
           <p:cNvPr id="9" name="Dia számának helye 8">
             <a:extLst>
               <a:ext uri="{FF2B5EF4-FFF2-40B4-BE49-F238E27FC236}">
-                <a16:creationId xmlns:a16="http://schemas.microsoft.com/office/drawing/2014/main" id="{EE0D2C2D-86DA-4ED2-8FC7-AC133DCD9171}"/>
+                <a16:creationId xmlns:a16="http://schemas.microsoft.com/office/drawing/2014/main" id="{F58439AA-788E-4513-BD2B-3B915235B8DA}"/>
               </a:ext>
             </a:extLst>
           </p:cNvPr>
@@ -1874,7 +1879,7 @@
     </p:spTree>
     <p:extLst>
       <p:ext uri="{BB962C8B-B14F-4D97-AF65-F5344CB8AC3E}">
-        <p14:creationId xmlns:p14="http://schemas.microsoft.com/office/powerpoint/2010/main" val="1918439197"/>
+        <p14:creationId xmlns:p14="http://schemas.microsoft.com/office/powerpoint/2010/main" val="1373889000"/>
       </p:ext>
     </p:extLst>
   </p:cSld>
@@ -1906,7 +1911,7 @@
           <p:cNvPr id="2" name="Cím 1">
             <a:extLst>
               <a:ext uri="{FF2B5EF4-FFF2-40B4-BE49-F238E27FC236}">
-                <a16:creationId xmlns:a16="http://schemas.microsoft.com/office/drawing/2014/main" id="{CFBDABD2-D533-4FC7-AE75-58445407289C}"/>
+                <a16:creationId xmlns:a16="http://schemas.microsoft.com/office/drawing/2014/main" id="{AB122B96-E7BE-412F-B1F5-3D4B3506CBD8}"/>
               </a:ext>
             </a:extLst>
           </p:cNvPr>
@@ -1934,7 +1939,7 @@
           <p:cNvPr id="3" name="Dátum helye 2">
             <a:extLst>
               <a:ext uri="{FF2B5EF4-FFF2-40B4-BE49-F238E27FC236}">
-                <a16:creationId xmlns:a16="http://schemas.microsoft.com/office/drawing/2014/main" id="{818242A9-6843-4B83-B0EB-B3008D81B35B}"/>
+                <a16:creationId xmlns:a16="http://schemas.microsoft.com/office/drawing/2014/main" id="{2AAD2F0D-FAC2-4F50-86D6-4BFD740FFC70}"/>
               </a:ext>
             </a:extLst>
           </p:cNvPr>
@@ -1952,7 +1957,7 @@
           <a:p>
             <a:fld id="{B9A16147-4286-4EA3-A7A6-0076531D1571}" type="datetimeFigureOut">
               <a:rPr lang="hu-HU" smtClean="0"/>
-              <a:t>2026.03.23.</a:t>
+              <a:t>2026.03.24.</a:t>
             </a:fld>
             <a:endParaRPr lang="hu-HU"/>
           </a:p>
@@ -1963,7 +1968,7 @@
           <p:cNvPr id="4" name="Élőláb helye 3">
             <a:extLst>
               <a:ext uri="{FF2B5EF4-FFF2-40B4-BE49-F238E27FC236}">
-                <a16:creationId xmlns:a16="http://schemas.microsoft.com/office/drawing/2014/main" id="{A488A0CE-D0FD-4A6D-A486-07FF0D30217F}"/>
+                <a16:creationId xmlns:a16="http://schemas.microsoft.com/office/drawing/2014/main" id="{1D6C7616-70E4-4A01-92F2-2C2DE09EC53F}"/>
               </a:ext>
             </a:extLst>
           </p:cNvPr>
@@ -1988,7 +1993,7 @@
           <p:cNvPr id="5" name="Dia számának helye 4">
             <a:extLst>
               <a:ext uri="{FF2B5EF4-FFF2-40B4-BE49-F238E27FC236}">
-                <a16:creationId xmlns:a16="http://schemas.microsoft.com/office/drawing/2014/main" id="{207EF9DE-1BA8-44AA-B3EE-29A5AFC666A7}"/>
+                <a16:creationId xmlns:a16="http://schemas.microsoft.com/office/drawing/2014/main" id="{D822B10D-32E8-4AE9-ACFE-ABD919348F2A}"/>
               </a:ext>
             </a:extLst>
           </p:cNvPr>
@@ -2015,7 +2020,7 @@
     </p:spTree>
     <p:extLst>
       <p:ext uri="{BB962C8B-B14F-4D97-AF65-F5344CB8AC3E}">
-        <p14:creationId xmlns:p14="http://schemas.microsoft.com/office/powerpoint/2010/main" val="268103997"/>
+        <p14:creationId xmlns:p14="http://schemas.microsoft.com/office/powerpoint/2010/main" val="661849287"/>
       </p:ext>
     </p:extLst>
   </p:cSld>
@@ -2047,7 +2052,7 @@
           <p:cNvPr id="2" name="Dátum helye 1">
             <a:extLst>
               <a:ext uri="{FF2B5EF4-FFF2-40B4-BE49-F238E27FC236}">
-                <a16:creationId xmlns:a16="http://schemas.microsoft.com/office/drawing/2014/main" id="{C4EBCEFD-52F2-4A37-A1A4-93D596B34627}"/>
+                <a16:creationId xmlns:a16="http://schemas.microsoft.com/office/drawing/2014/main" id="{C7E85A7F-D7EE-4432-93AC-EB0B32D22FD8}"/>
               </a:ext>
             </a:extLst>
           </p:cNvPr>
@@ -2065,7 +2070,7 @@
           <a:p>
             <a:fld id="{B9A16147-4286-4EA3-A7A6-0076531D1571}" type="datetimeFigureOut">
               <a:rPr lang="hu-HU" smtClean="0"/>
-              <a:t>2026.03.23.</a:t>
+              <a:t>2026.03.24.</a:t>
             </a:fld>
             <a:endParaRPr lang="hu-HU"/>
           </a:p>
@@ -2076,7 +2081,7 @@
           <p:cNvPr id="3" name="Élőláb helye 2">
             <a:extLst>
               <a:ext uri="{FF2B5EF4-FFF2-40B4-BE49-F238E27FC236}">
-                <a16:creationId xmlns:a16="http://schemas.microsoft.com/office/drawing/2014/main" id="{CCD11FDB-7810-410F-8140-A6380DFC2C08}"/>
+                <a16:creationId xmlns:a16="http://schemas.microsoft.com/office/drawing/2014/main" id="{BF68B7BC-A33E-4A29-A25B-2CDE36BB2594}"/>
               </a:ext>
             </a:extLst>
           </p:cNvPr>
@@ -2101,7 +2106,7 @@
           <p:cNvPr id="4" name="Dia számának helye 3">
             <a:extLst>
               <a:ext uri="{FF2B5EF4-FFF2-40B4-BE49-F238E27FC236}">
-                <a16:creationId xmlns:a16="http://schemas.microsoft.com/office/drawing/2014/main" id="{A2A2DF0A-1FAE-4B67-99B7-38F524B659B6}"/>
+                <a16:creationId xmlns:a16="http://schemas.microsoft.com/office/drawing/2014/main" id="{CF95EF4A-0DF4-4D48-94DA-5A07E7091A8D}"/>
               </a:ext>
             </a:extLst>
           </p:cNvPr>
@@ -2128,7 +2133,7 @@
     </p:spTree>
     <p:extLst>
       <p:ext uri="{BB962C8B-B14F-4D97-AF65-F5344CB8AC3E}">
-        <p14:creationId xmlns:p14="http://schemas.microsoft.com/office/powerpoint/2010/main" val="1763025713"/>
+        <p14:creationId xmlns:p14="http://schemas.microsoft.com/office/powerpoint/2010/main" val="242792577"/>
       </p:ext>
     </p:extLst>
   </p:cSld>
@@ -2160,7 +2165,7 @@
           <p:cNvPr id="2" name="Cím 1">
             <a:extLst>
               <a:ext uri="{FF2B5EF4-FFF2-40B4-BE49-F238E27FC236}">
-                <a16:creationId xmlns:a16="http://schemas.microsoft.com/office/drawing/2014/main" id="{569F68E7-674D-4B92-8F35-4268B5098C31}"/>
+                <a16:creationId xmlns:a16="http://schemas.microsoft.com/office/drawing/2014/main" id="{B948167E-A70B-433F-B4F0-98ED7CC9C485}"/>
               </a:ext>
             </a:extLst>
           </p:cNvPr>
@@ -2197,7 +2202,7 @@
           <p:cNvPr id="3" name="Tartalom helye 2">
             <a:extLst>
               <a:ext uri="{FF2B5EF4-FFF2-40B4-BE49-F238E27FC236}">
-                <a16:creationId xmlns:a16="http://schemas.microsoft.com/office/drawing/2014/main" id="{7761AD8C-62A1-4AF8-978C-4D1952AD485B}"/>
+                <a16:creationId xmlns:a16="http://schemas.microsoft.com/office/drawing/2014/main" id="{0AE1643A-F5A9-4994-9697-C6EEBE2AFC5B}"/>
               </a:ext>
             </a:extLst>
           </p:cNvPr>
@@ -2287,7 +2292,7 @@
           <p:cNvPr id="4" name="Szöveg helye 3">
             <a:extLst>
               <a:ext uri="{FF2B5EF4-FFF2-40B4-BE49-F238E27FC236}">
-                <a16:creationId xmlns:a16="http://schemas.microsoft.com/office/drawing/2014/main" id="{BD35994F-8DA8-4E88-96FC-7CFCD5601FEC}"/>
+                <a16:creationId xmlns:a16="http://schemas.microsoft.com/office/drawing/2014/main" id="{36247BF7-39B2-4B2B-BC67-35C3EBA48355}"/>
               </a:ext>
             </a:extLst>
           </p:cNvPr>
@@ -2358,7 +2363,7 @@
           <p:cNvPr id="5" name="Dátum helye 4">
             <a:extLst>
               <a:ext uri="{FF2B5EF4-FFF2-40B4-BE49-F238E27FC236}">
-                <a16:creationId xmlns:a16="http://schemas.microsoft.com/office/drawing/2014/main" id="{499AE657-8585-4135-8921-89315FAAAEAB}"/>
+                <a16:creationId xmlns:a16="http://schemas.microsoft.com/office/drawing/2014/main" id="{7751FF3D-943B-407A-ABD8-997EA7533D29}"/>
               </a:ext>
             </a:extLst>
           </p:cNvPr>
@@ -2376,7 +2381,7 @@
           <a:p>
             <a:fld id="{B9A16147-4286-4EA3-A7A6-0076531D1571}" type="datetimeFigureOut">
               <a:rPr lang="hu-HU" smtClean="0"/>
-              <a:t>2026.03.23.</a:t>
+              <a:t>2026.03.24.</a:t>
             </a:fld>
             <a:endParaRPr lang="hu-HU"/>
           </a:p>
@@ -2387,7 +2392,7 @@
           <p:cNvPr id="6" name="Élőláb helye 5">
             <a:extLst>
               <a:ext uri="{FF2B5EF4-FFF2-40B4-BE49-F238E27FC236}">
-                <a16:creationId xmlns:a16="http://schemas.microsoft.com/office/drawing/2014/main" id="{E656F6F6-D7A4-462E-B116-BC1DDA9B8EFF}"/>
+                <a16:creationId xmlns:a16="http://schemas.microsoft.com/office/drawing/2014/main" id="{709A5FA1-CCB8-4295-B7EC-39D5262244AD}"/>
               </a:ext>
             </a:extLst>
           </p:cNvPr>
@@ -2412,7 +2417,7 @@
           <p:cNvPr id="7" name="Dia számának helye 6">
             <a:extLst>
               <a:ext uri="{FF2B5EF4-FFF2-40B4-BE49-F238E27FC236}">
-                <a16:creationId xmlns:a16="http://schemas.microsoft.com/office/drawing/2014/main" id="{F5822D9E-21E2-4E27-ABC8-A0C2BEC29647}"/>
+                <a16:creationId xmlns:a16="http://schemas.microsoft.com/office/drawing/2014/main" id="{24359DE9-930A-40A7-A58A-440CD760C984}"/>
               </a:ext>
             </a:extLst>
           </p:cNvPr>
@@ -2439,7 +2444,7 @@
     </p:spTree>
     <p:extLst>
       <p:ext uri="{BB962C8B-B14F-4D97-AF65-F5344CB8AC3E}">
-        <p14:creationId xmlns:p14="http://schemas.microsoft.com/office/powerpoint/2010/main" val="115539626"/>
+        <p14:creationId xmlns:p14="http://schemas.microsoft.com/office/powerpoint/2010/main" val="853796146"/>
       </p:ext>
     </p:extLst>
   </p:cSld>
@@ -2471,7 +2476,7 @@
           <p:cNvPr id="2" name="Cím 1">
             <a:extLst>
               <a:ext uri="{FF2B5EF4-FFF2-40B4-BE49-F238E27FC236}">
-                <a16:creationId xmlns:a16="http://schemas.microsoft.com/office/drawing/2014/main" id="{14337116-32F3-4E12-9C2E-C4A20091437C}"/>
+                <a16:creationId xmlns:a16="http://schemas.microsoft.com/office/drawing/2014/main" id="{52BC4121-2676-46EE-B38B-2973D1B6DEC4}"/>
               </a:ext>
             </a:extLst>
           </p:cNvPr>
@@ -2508,7 +2513,7 @@
           <p:cNvPr id="3" name="Kép helye 2">
             <a:extLst>
               <a:ext uri="{FF2B5EF4-FFF2-40B4-BE49-F238E27FC236}">
-                <a16:creationId xmlns:a16="http://schemas.microsoft.com/office/drawing/2014/main" id="{FC5BA61D-55F9-4F72-8CDB-0A624B794B21}"/>
+                <a16:creationId xmlns:a16="http://schemas.microsoft.com/office/drawing/2014/main" id="{D37804B7-03BB-4713-8FE5-E42993B43854}"/>
               </a:ext>
             </a:extLst>
           </p:cNvPr>
@@ -2575,7 +2580,7 @@
           <p:cNvPr id="4" name="Szöveg helye 3">
             <a:extLst>
               <a:ext uri="{FF2B5EF4-FFF2-40B4-BE49-F238E27FC236}">
-                <a16:creationId xmlns:a16="http://schemas.microsoft.com/office/drawing/2014/main" id="{96727401-45A5-428B-82AF-1676666B798C}"/>
+                <a16:creationId xmlns:a16="http://schemas.microsoft.com/office/drawing/2014/main" id="{5F344376-4E20-465D-8F1A-1F710356B2C5}"/>
               </a:ext>
             </a:extLst>
           </p:cNvPr>
@@ -2646,7 +2651,7 @@
           <p:cNvPr id="5" name="Dátum helye 4">
             <a:extLst>
               <a:ext uri="{FF2B5EF4-FFF2-40B4-BE49-F238E27FC236}">
-                <a16:creationId xmlns:a16="http://schemas.microsoft.com/office/drawing/2014/main" id="{20DD7C55-55BE-418B-837F-9C4785DBDD68}"/>
+                <a16:creationId xmlns:a16="http://schemas.microsoft.com/office/drawing/2014/main" id="{032577DC-9226-47C7-ABD5-36B5A8A67D5B}"/>
               </a:ext>
             </a:extLst>
           </p:cNvPr>
@@ -2664,7 +2669,7 @@
           <a:p>
             <a:fld id="{B9A16147-4286-4EA3-A7A6-0076531D1571}" type="datetimeFigureOut">
               <a:rPr lang="hu-HU" smtClean="0"/>
-              <a:t>2026.03.23.</a:t>
+              <a:t>2026.03.24.</a:t>
             </a:fld>
             <a:endParaRPr lang="hu-HU"/>
           </a:p>
@@ -2675,7 +2680,7 @@
           <p:cNvPr id="6" name="Élőláb helye 5">
             <a:extLst>
               <a:ext uri="{FF2B5EF4-FFF2-40B4-BE49-F238E27FC236}">
-                <a16:creationId xmlns:a16="http://schemas.microsoft.com/office/drawing/2014/main" id="{C5AD76BA-1960-43EC-90BF-1CF17595A4A8}"/>
+                <a16:creationId xmlns:a16="http://schemas.microsoft.com/office/drawing/2014/main" id="{2D57779C-2F76-4B3D-93C1-98CE9B84B986}"/>
               </a:ext>
             </a:extLst>
           </p:cNvPr>
@@ -2700,7 +2705,7 @@
           <p:cNvPr id="7" name="Dia számának helye 6">
             <a:extLst>
               <a:ext uri="{FF2B5EF4-FFF2-40B4-BE49-F238E27FC236}">
-                <a16:creationId xmlns:a16="http://schemas.microsoft.com/office/drawing/2014/main" id="{A3B0AEE5-613B-406D-A7A3-29C5DD96DC6A}"/>
+                <a16:creationId xmlns:a16="http://schemas.microsoft.com/office/drawing/2014/main" id="{AA8050A2-AFF9-4C0E-B473-6190588276CF}"/>
               </a:ext>
             </a:extLst>
           </p:cNvPr>
@@ -2727,7 +2732,7 @@
     </p:spTree>
     <p:extLst>
       <p:ext uri="{BB962C8B-B14F-4D97-AF65-F5344CB8AC3E}">
-        <p14:creationId xmlns:p14="http://schemas.microsoft.com/office/powerpoint/2010/main" val="2203248330"/>
+        <p14:creationId xmlns:p14="http://schemas.microsoft.com/office/powerpoint/2010/main" val="2903711562"/>
       </p:ext>
     </p:extLst>
   </p:cSld>
@@ -2764,7 +2769,7 @@
           <p:cNvPr id="2" name="Cím helye 1">
             <a:extLst>
               <a:ext uri="{FF2B5EF4-FFF2-40B4-BE49-F238E27FC236}">
-                <a16:creationId xmlns:a16="http://schemas.microsoft.com/office/drawing/2014/main" id="{EEBD4559-1A2C-4C6B-84E0-1E864E1EA589}"/>
+                <a16:creationId xmlns:a16="http://schemas.microsoft.com/office/drawing/2014/main" id="{8480FCED-BF3A-405A-9153-999E303B4166}"/>
               </a:ext>
             </a:extLst>
           </p:cNvPr>
@@ -2802,7 +2807,7 @@
           <p:cNvPr id="3" name="Szöveg helye 2">
             <a:extLst>
               <a:ext uri="{FF2B5EF4-FFF2-40B4-BE49-F238E27FC236}">
-                <a16:creationId xmlns:a16="http://schemas.microsoft.com/office/drawing/2014/main" id="{0D2BE726-8937-44EC-8539-DA6DD22DA57B}"/>
+                <a16:creationId xmlns:a16="http://schemas.microsoft.com/office/drawing/2014/main" id="{19A9BC46-7E58-4239-B6EF-025BD408B717}"/>
               </a:ext>
             </a:extLst>
           </p:cNvPr>
@@ -2869,7 +2874,7 @@
           <p:cNvPr id="4" name="Dátum helye 3">
             <a:extLst>
               <a:ext uri="{FF2B5EF4-FFF2-40B4-BE49-F238E27FC236}">
-                <a16:creationId xmlns:a16="http://schemas.microsoft.com/office/drawing/2014/main" id="{5E5E4BC6-738C-404E-A62E-B3258094C7E0}"/>
+                <a16:creationId xmlns:a16="http://schemas.microsoft.com/office/drawing/2014/main" id="{83A2597E-0ED6-4DBC-AEAE-AA8C7F17949F}"/>
               </a:ext>
             </a:extLst>
           </p:cNvPr>
@@ -2905,7 +2910,7 @@
           <a:p>
             <a:fld id="{B9A16147-4286-4EA3-A7A6-0076531D1571}" type="datetimeFigureOut">
               <a:rPr lang="hu-HU" smtClean="0"/>
-              <a:t>2026.03.23.</a:t>
+              <a:t>2026.03.24.</a:t>
             </a:fld>
             <a:endParaRPr lang="hu-HU"/>
           </a:p>
@@ -2916,7 +2921,7 @@
           <p:cNvPr id="5" name="Élőláb helye 4">
             <a:extLst>
               <a:ext uri="{FF2B5EF4-FFF2-40B4-BE49-F238E27FC236}">
-                <a16:creationId xmlns:a16="http://schemas.microsoft.com/office/drawing/2014/main" id="{309B2AA5-664D-41BE-9D68-5AA69C677048}"/>
+                <a16:creationId xmlns:a16="http://schemas.microsoft.com/office/drawing/2014/main" id="{D785A5D5-1600-4A2B-997C-BE886B60ED8D}"/>
               </a:ext>
             </a:extLst>
           </p:cNvPr>
@@ -2959,7 +2964,7 @@
           <p:cNvPr id="6" name="Dia számának helye 5">
             <a:extLst>
               <a:ext uri="{FF2B5EF4-FFF2-40B4-BE49-F238E27FC236}">
-                <a16:creationId xmlns:a16="http://schemas.microsoft.com/office/drawing/2014/main" id="{AF9CE937-7A80-4B7F-AB68-45C9EF95FF7A}"/>
+                <a16:creationId xmlns:a16="http://schemas.microsoft.com/office/drawing/2014/main" id="{03B43265-CB7B-4468-8F3C-E548BBCFFEB7}"/>
               </a:ext>
             </a:extLst>
           </p:cNvPr>
@@ -3004,23 +3009,23 @@
     </p:spTree>
     <p:extLst>
       <p:ext uri="{BB962C8B-B14F-4D97-AF65-F5344CB8AC3E}">
-        <p14:creationId xmlns:p14="http://schemas.microsoft.com/office/powerpoint/2010/main" val="1605960276"/>
+        <p14:creationId xmlns:p14="http://schemas.microsoft.com/office/powerpoint/2010/main" val="3302876707"/>
       </p:ext>
     </p:extLst>
   </p:cSld>
   <p:clrMap bg1="lt1" tx1="dk1" bg2="lt2" tx2="dk2" accent1="accent1" accent2="accent2" accent3="accent3" accent4="accent4" accent5="accent5" accent6="accent6" hlink="hlink" folHlink="folHlink"/>
   <p:sldLayoutIdLst>
-    <p:sldLayoutId id="2147483649" r:id="rId1"/>
-    <p:sldLayoutId id="2147483650" r:id="rId2"/>
-    <p:sldLayoutId id="2147483651" r:id="rId3"/>
-    <p:sldLayoutId id="2147483652" r:id="rId4"/>
-    <p:sldLayoutId id="2147483653" r:id="rId5"/>
-    <p:sldLayoutId id="2147483654" r:id="rId6"/>
-    <p:sldLayoutId id="2147483655" r:id="rId7"/>
-    <p:sldLayoutId id="2147483656" r:id="rId8"/>
-    <p:sldLayoutId id="2147483657" r:id="rId9"/>
-    <p:sldLayoutId id="2147483658" r:id="rId10"/>
-    <p:sldLayoutId id="2147483659" r:id="rId11"/>
+    <p:sldLayoutId id="2147483678" r:id="rId1"/>
+    <p:sldLayoutId id="2147483679" r:id="rId2"/>
+    <p:sldLayoutId id="2147483680" r:id="rId3"/>
+    <p:sldLayoutId id="2147483681" r:id="rId4"/>
+    <p:sldLayoutId id="2147483682" r:id="rId5"/>
+    <p:sldLayoutId id="2147483683" r:id="rId6"/>
+    <p:sldLayoutId id="2147483684" r:id="rId7"/>
+    <p:sldLayoutId id="2147483685" r:id="rId8"/>
+    <p:sldLayoutId id="2147483686" r:id="rId9"/>
+    <p:sldLayoutId id="2147483687" r:id="rId10"/>
+    <p:sldLayoutId id="2147483688" r:id="rId11"/>
   </p:sldLayoutIdLst>
   <p:txStyles>
     <p:titleStyle>
@@ -3340,7 +3345,7 @@
         </p:nvSpPr>
         <p:spPr>
           <a:xfrm>
-            <a:off x="1524000" y="1063833"/>
+            <a:off x="1593804" y="1336913"/>
             <a:ext cx="9144000" cy="2387600"/>
           </a:xfrm>
         </p:spPr>
@@ -3350,7 +3355,7 @@
           <a:p>
             <a:r>
               <a:rPr lang="hu-HU" dirty="0"/>
-              <a:t>cím</a:t>
+              <a:t>Villám Meló	</a:t>
             </a:r>
           </a:p>
         </p:txBody>
@@ -3371,18 +3376,1064 @@
             <p:ph type="subTitle" idx="1"/>
           </p:nvPr>
         </p:nvSpPr>
-        <p:spPr/>
-        <p:txBody>
-          <a:bodyPr/>
+        <p:spPr>
+          <a:xfrm>
+            <a:off x="9351818" y="5084474"/>
+            <a:ext cx="2632364" cy="1655762"/>
+          </a:xfrm>
+        </p:spPr>
+        <p:txBody>
+          <a:bodyPr>
+            <a:normAutofit fontScale="92500" lnSpcReduction="20000"/>
+          </a:bodyPr>
           <a:lstStyle/>
           <a:p>
+            <a:pPr>
+              <a:spcAft>
+                <a:spcPts val="1800"/>
+              </a:spcAft>
+            </a:pPr>
             <a:r>
               <a:rPr lang="hu-HU" dirty="0"/>
-              <a:t>-</a:t>
-            </a:r>
-          </a:p>
-        </p:txBody>
-      </p:sp>
+              <a:t>Készítette:</a:t>
+            </a:r>
+          </a:p>
+          <a:p>
+            <a:r>
+              <a:rPr lang="hu-HU" dirty="0"/>
+              <a:t>Boros Dániel</a:t>
+            </a:r>
+          </a:p>
+          <a:p>
+            <a:r>
+              <a:rPr lang="hu-HU" dirty="0"/>
+              <a:t>Hencsey Dorina</a:t>
+            </a:r>
+          </a:p>
+          <a:p>
+            <a:r>
+              <a:rPr lang="hu-HU" dirty="0" err="1"/>
+              <a:t>Kléber</a:t>
+            </a:r>
+            <a:r>
+              <a:rPr lang="hu-HU" dirty="0"/>
+              <a:t> Gergely László</a:t>
+            </a:r>
+          </a:p>
+        </p:txBody>
+      </p:sp>
+      <p:grpSp>
+        <p:nvGrpSpPr>
+          <p:cNvPr id="4" name="Csoportba foglalás 3">
+            <a:extLst>
+              <a:ext uri="{FF2B5EF4-FFF2-40B4-BE49-F238E27FC236}">
+                <a16:creationId xmlns:a16="http://schemas.microsoft.com/office/drawing/2014/main" id="{10485443-E17B-40F0-982D-20118D0D208F}"/>
+              </a:ext>
+            </a:extLst>
+          </p:cNvPr>
+          <p:cNvGrpSpPr/>
+          <p:nvPr/>
+        </p:nvGrpSpPr>
+        <p:grpSpPr>
+          <a:xfrm>
+            <a:off x="2840182" y="105195"/>
+            <a:ext cx="6511636" cy="6520604"/>
+            <a:chOff x="2412256" y="1217022"/>
+            <a:chExt cx="4505659" cy="4511867"/>
+          </a:xfrm>
+        </p:grpSpPr>
+        <p:sp>
+          <p:nvSpPr>
+            <p:cNvPr id="5" name="Szabadkézi sokszög: alakzat 4">
+              <a:extLst>
+                <a:ext uri="{FF2B5EF4-FFF2-40B4-BE49-F238E27FC236}">
+                  <a16:creationId xmlns:a16="http://schemas.microsoft.com/office/drawing/2014/main" id="{9C41E1AF-D323-4C3E-B51D-7AD49110318C}"/>
+                </a:ext>
+              </a:extLst>
+            </p:cNvPr>
+            <p:cNvSpPr/>
+            <p:nvPr/>
+          </p:nvSpPr>
+          <p:spPr>
+            <a:xfrm>
+              <a:off x="4688114" y="1217022"/>
+              <a:ext cx="1707997" cy="1322031"/>
+            </a:xfrm>
+            <a:custGeom>
+              <a:avLst/>
+              <a:gdLst>
+                <a:gd name="connsiteX0" fmla="*/ 0 w 1779324"/>
+                <a:gd name="connsiteY0" fmla="*/ 0 h 1377240"/>
+                <a:gd name="connsiteX1" fmla="*/ 1779324 w 1779324"/>
+                <a:gd name="connsiteY1" fmla="*/ 856878 h 1377240"/>
+                <a:gd name="connsiteX2" fmla="*/ 1126811 w 1779324"/>
+                <a:gd name="connsiteY2" fmla="*/ 1377240 h 1377240"/>
+                <a:gd name="connsiteX3" fmla="*/ 1100531 w 1779324"/>
+                <a:gd name="connsiteY3" fmla="*/ 1342097 h 1377240"/>
+                <a:gd name="connsiteX4" fmla="*/ 133550 w 1779324"/>
+                <a:gd name="connsiteY4" fmla="*/ 823876 h 1377240"/>
+                <a:gd name="connsiteX5" fmla="*/ 0 w 1779324"/>
+                <a:gd name="connsiteY5" fmla="*/ 817132 h 1377240"/>
+              </a:gdLst>
+              <a:ahLst/>
+              <a:cxnLst>
+                <a:cxn ang="0">
+                  <a:pos x="connsiteX0" y="connsiteY0"/>
+                </a:cxn>
+                <a:cxn ang="0">
+                  <a:pos x="connsiteX1" y="connsiteY1"/>
+                </a:cxn>
+                <a:cxn ang="0">
+                  <a:pos x="connsiteX2" y="connsiteY2"/>
+                </a:cxn>
+                <a:cxn ang="0">
+                  <a:pos x="connsiteX3" y="connsiteY3"/>
+                </a:cxn>
+                <a:cxn ang="0">
+                  <a:pos x="connsiteX4" y="connsiteY4"/>
+                </a:cxn>
+                <a:cxn ang="0">
+                  <a:pos x="connsiteX5" y="connsiteY5"/>
+                </a:cxn>
+              </a:cxnLst>
+              <a:rect l="l" t="t" r="r" b="b"/>
+              <a:pathLst>
+                <a:path w="1779324" h="1377240">
+                  <a:moveTo>
+                    <a:pt x="0" y="0"/>
+                  </a:moveTo>
+                  <a:cubicBezTo>
+                    <a:pt x="692595" y="0"/>
+                    <a:pt x="1347499" y="315385"/>
+                    <a:pt x="1779324" y="856878"/>
+                  </a:cubicBezTo>
+                  <a:lnTo>
+                    <a:pt x="1126811" y="1377240"/>
+                  </a:lnTo>
+                  <a:lnTo>
+                    <a:pt x="1100531" y="1342097"/>
+                  </a:lnTo>
+                  <a:cubicBezTo>
+                    <a:pt x="865020" y="1056723"/>
+                    <a:pt x="522040" y="863329"/>
+                    <a:pt x="133550" y="823876"/>
+                  </a:cubicBezTo>
+                  <a:lnTo>
+                    <a:pt x="0" y="817132"/>
+                  </a:lnTo>
+                  <a:close/>
+                </a:path>
+              </a:pathLst>
+            </a:custGeom>
+          </p:spPr>
+          <p:style>
+            <a:lnRef idx="2">
+              <a:schemeClr val="lt1">
+                <a:hueOff val="0"/>
+                <a:satOff val="0"/>
+                <a:lumOff val="0"/>
+                <a:alphaOff val="0"/>
+              </a:schemeClr>
+            </a:lnRef>
+            <a:fillRef idx="1">
+              <a:schemeClr val="accent1">
+                <a:hueOff val="0"/>
+                <a:satOff val="0"/>
+                <a:lumOff val="0"/>
+                <a:alphaOff val="0"/>
+              </a:schemeClr>
+            </a:fillRef>
+            <a:effectRef idx="0">
+              <a:schemeClr val="accent1">
+                <a:hueOff val="0"/>
+                <a:satOff val="0"/>
+                <a:lumOff val="0"/>
+                <a:alphaOff val="0"/>
+              </a:schemeClr>
+            </a:effectRef>
+            <a:fontRef idx="minor">
+              <a:schemeClr val="lt1"/>
+            </a:fontRef>
+          </p:style>
+          <p:txBody>
+            <a:bodyPr spcFirstLastPara="0" vert="horz" wrap="square" lIns="2355105" tIns="467783" rIns="1018862" bIns="3366771" numCol="1" spcCol="1270" anchor="ctr" anchorCtr="0">
+              <a:noAutofit/>
+            </a:bodyPr>
+            <a:lstStyle/>
+            <a:p>
+              <a:pPr marL="0" lvl="0" indent="0" algn="ctr" defTabSz="1200150">
+                <a:lnSpc>
+                  <a:spcPct val="90000"/>
+                </a:lnSpc>
+                <a:spcBef>
+                  <a:spcPct val="0"/>
+                </a:spcBef>
+                <a:spcAft>
+                  <a:spcPct val="35000"/>
+                </a:spcAft>
+                <a:buNone/>
+              </a:pPr>
+              <a:endParaRPr lang="hu-HU" sz="2700" kern="1200" dirty="0"/>
+            </a:p>
+          </p:txBody>
+        </p:sp>
+        <p:sp>
+          <p:nvSpPr>
+            <p:cNvPr id="6" name="Szabadkézi sokszög: alakzat 5">
+              <a:extLst>
+                <a:ext uri="{FF2B5EF4-FFF2-40B4-BE49-F238E27FC236}">
+                  <a16:creationId xmlns:a16="http://schemas.microsoft.com/office/drawing/2014/main" id="{97F88542-9739-4F43-BEC6-A65DAE9E25C9}"/>
+                </a:ext>
+              </a:extLst>
+            </p:cNvPr>
+            <p:cNvSpPr/>
+            <p:nvPr/>
+          </p:nvSpPr>
+          <p:spPr>
+            <a:xfrm>
+              <a:off x="5814927" y="2073900"/>
+              <a:ext cx="1102988" cy="1848202"/>
+            </a:xfrm>
+            <a:custGeom>
+              <a:avLst/>
+              <a:gdLst>
+                <a:gd name="connsiteX0" fmla="*/ 652513 w 1149049"/>
+                <a:gd name="connsiteY0" fmla="*/ 0 h 1925384"/>
+                <a:gd name="connsiteX1" fmla="*/ 1091969 w 1149049"/>
+                <a:gd name="connsiteY1" fmla="*/ 1925384 h 1925384"/>
+                <a:gd name="connsiteX2" fmla="*/ 263661 w 1149049"/>
+                <a:gd name="connsiteY2" fmla="*/ 1736328 h 1925384"/>
+                <a:gd name="connsiteX3" fmla="*/ 274235 w 1149049"/>
+                <a:gd name="connsiteY3" fmla="*/ 1695205 h 1925384"/>
+                <a:gd name="connsiteX4" fmla="*/ 303583 w 1149049"/>
+                <a:gd name="connsiteY4" fmla="*/ 1404080 h 1925384"/>
+                <a:gd name="connsiteX5" fmla="*/ 56878 w 1149049"/>
+                <a:gd name="connsiteY5" fmla="*/ 596424 h 1925384"/>
+                <a:gd name="connsiteX6" fmla="*/ 0 w 1149049"/>
+                <a:gd name="connsiteY6" fmla="*/ 520362 h 1925384"/>
+              </a:gdLst>
+              <a:ahLst/>
+              <a:cxnLst>
+                <a:cxn ang="0">
+                  <a:pos x="connsiteX0" y="connsiteY0"/>
+                </a:cxn>
+                <a:cxn ang="0">
+                  <a:pos x="connsiteX1" y="connsiteY1"/>
+                </a:cxn>
+                <a:cxn ang="0">
+                  <a:pos x="connsiteX2" y="connsiteY2"/>
+                </a:cxn>
+                <a:cxn ang="0">
+                  <a:pos x="connsiteX3" y="connsiteY3"/>
+                </a:cxn>
+                <a:cxn ang="0">
+                  <a:pos x="connsiteX4" y="connsiteY4"/>
+                </a:cxn>
+                <a:cxn ang="0">
+                  <a:pos x="connsiteX5" y="connsiteY5"/>
+                </a:cxn>
+                <a:cxn ang="0">
+                  <a:pos x="connsiteX6" y="connsiteY6"/>
+                </a:cxn>
+              </a:cxnLst>
+              <a:rect l="l" t="t" r="r" b="b"/>
+              <a:pathLst>
+                <a:path w="1149049" h="1925384">
+                  <a:moveTo>
+                    <a:pt x="652513" y="0"/>
+                  </a:moveTo>
+                  <a:cubicBezTo>
+                    <a:pt x="1084338" y="541492"/>
+                    <a:pt x="1246085" y="1250155"/>
+                    <a:pt x="1091969" y="1925384"/>
+                  </a:cubicBezTo>
+                  <a:lnTo>
+                    <a:pt x="263661" y="1736328"/>
+                  </a:lnTo>
+                  <a:lnTo>
+                    <a:pt x="274235" y="1695205"/>
+                  </a:lnTo>
+                  <a:cubicBezTo>
+                    <a:pt x="293478" y="1601169"/>
+                    <a:pt x="303583" y="1503805"/>
+                    <a:pt x="303583" y="1404080"/>
+                  </a:cubicBezTo>
+                  <a:cubicBezTo>
+                    <a:pt x="303583" y="1104906"/>
+                    <a:pt x="212635" y="826974"/>
+                    <a:pt x="56878" y="596424"/>
+                  </a:cubicBezTo>
+                  <a:lnTo>
+                    <a:pt x="0" y="520362"/>
+                  </a:lnTo>
+                  <a:close/>
+                </a:path>
+              </a:pathLst>
+            </a:custGeom>
+          </p:spPr>
+          <p:style>
+            <a:lnRef idx="2">
+              <a:schemeClr val="lt1">
+                <a:hueOff val="0"/>
+                <a:satOff val="0"/>
+                <a:lumOff val="0"/>
+                <a:alphaOff val="0"/>
+              </a:schemeClr>
+            </a:lnRef>
+            <a:fillRef idx="1">
+              <a:schemeClr val="accent1">
+                <a:hueOff val="0"/>
+                <a:satOff val="0"/>
+                <a:lumOff val="0"/>
+                <a:alphaOff val="0"/>
+              </a:schemeClr>
+            </a:fillRef>
+            <a:effectRef idx="0">
+              <a:schemeClr val="accent1">
+                <a:hueOff val="0"/>
+                <a:satOff val="0"/>
+                <a:lumOff val="0"/>
+                <a:alphaOff val="0"/>
+              </a:schemeClr>
+            </a:effectRef>
+            <a:fontRef idx="minor">
+              <a:schemeClr val="lt1"/>
+            </a:fontRef>
+          </p:style>
+          <p:txBody>
+            <a:bodyPr spcFirstLastPara="0" vert="horz" wrap="square" lIns="3179233" tIns="1689100" rIns="177293" bIns="2149687" numCol="1" spcCol="1270" anchor="ctr" anchorCtr="0">
+              <a:noAutofit/>
+            </a:bodyPr>
+            <a:lstStyle/>
+            <a:p>
+              <a:pPr marL="0" lvl="0" indent="0" algn="ctr" defTabSz="2222500">
+                <a:lnSpc>
+                  <a:spcPct val="90000"/>
+                </a:lnSpc>
+                <a:spcBef>
+                  <a:spcPct val="0"/>
+                </a:spcBef>
+                <a:spcAft>
+                  <a:spcPct val="35000"/>
+                </a:spcAft>
+                <a:buNone/>
+              </a:pPr>
+              <a:endParaRPr lang="hu-HU" sz="5000" kern="1200"/>
+            </a:p>
+          </p:txBody>
+        </p:sp>
+        <p:sp>
+          <p:nvSpPr>
+            <p:cNvPr id="7" name="Szabadkézi sokszög: alakzat 6">
+              <a:extLst>
+                <a:ext uri="{FF2B5EF4-FFF2-40B4-BE49-F238E27FC236}">
+                  <a16:creationId xmlns:a16="http://schemas.microsoft.com/office/drawing/2014/main" id="{E5467805-A1BE-4064-91C5-B6205F91CD02}"/>
+                </a:ext>
+              </a:extLst>
+            </p:cNvPr>
+            <p:cNvSpPr/>
+            <p:nvPr/>
+          </p:nvSpPr>
+          <p:spPr>
+            <a:xfrm>
+              <a:off x="5305801" y="3810229"/>
+              <a:ext cx="1536912" cy="1663621"/>
+            </a:xfrm>
+            <a:custGeom>
+              <a:avLst/>
+              <a:gdLst>
+                <a:gd name="connsiteX0" fmla="*/ 772787 w 1601095"/>
+                <a:gd name="connsiteY0" fmla="*/ 0 h 1733095"/>
+                <a:gd name="connsiteX1" fmla="*/ 1601095 w 1601095"/>
+                <a:gd name="connsiteY1" fmla="*/ 189056 h 1733095"/>
+                <a:gd name="connsiteX2" fmla="*/ 369765 w 1601095"/>
+                <a:gd name="connsiteY2" fmla="*/ 1733095 h 1733095"/>
+                <a:gd name="connsiteX3" fmla="*/ 0 w 1601095"/>
+                <a:gd name="connsiteY3" fmla="*/ 965269 h 1733095"/>
+                <a:gd name="connsiteX4" fmla="*/ 56723 w 1601095"/>
+                <a:gd name="connsiteY4" fmla="*/ 937944 h 1733095"/>
+                <a:gd name="connsiteX5" fmla="*/ 747766 w 1601095"/>
+                <a:gd name="connsiteY5" fmla="*/ 97314 h 1733095"/>
+              </a:gdLst>
+              <a:ahLst/>
+              <a:cxnLst>
+                <a:cxn ang="0">
+                  <a:pos x="connsiteX0" y="connsiteY0"/>
+                </a:cxn>
+                <a:cxn ang="0">
+                  <a:pos x="connsiteX1" y="connsiteY1"/>
+                </a:cxn>
+                <a:cxn ang="0">
+                  <a:pos x="connsiteX2" y="connsiteY2"/>
+                </a:cxn>
+                <a:cxn ang="0">
+                  <a:pos x="connsiteX3" y="connsiteY3"/>
+                </a:cxn>
+                <a:cxn ang="0">
+                  <a:pos x="connsiteX4" y="connsiteY4"/>
+                </a:cxn>
+                <a:cxn ang="0">
+                  <a:pos x="connsiteX5" y="connsiteY5"/>
+                </a:cxn>
+              </a:cxnLst>
+              <a:rect l="l" t="t" r="r" b="b"/>
+              <a:pathLst>
+                <a:path w="1601095" h="1733095">
+                  <a:moveTo>
+                    <a:pt x="772787" y="0"/>
+                  </a:moveTo>
+                  <a:lnTo>
+                    <a:pt x="1601095" y="189056"/>
+                  </a:lnTo>
+                  <a:cubicBezTo>
+                    <a:pt x="1446978" y="864286"/>
+                    <a:pt x="993771" y="1432590"/>
+                    <a:pt x="369765" y="1733095"/>
+                  </a:cubicBezTo>
+                  <a:lnTo>
+                    <a:pt x="0" y="965269"/>
+                  </a:lnTo>
+                  <a:lnTo>
+                    <a:pt x="56723" y="937944"/>
+                  </a:lnTo>
+                  <a:cubicBezTo>
+                    <a:pt x="384213" y="760040"/>
+                    <a:pt x="635215" y="459177"/>
+                    <a:pt x="747766" y="97314"/>
+                  </a:cubicBezTo>
+                  <a:close/>
+                </a:path>
+              </a:pathLst>
+            </a:custGeom>
+          </p:spPr>
+          <p:style>
+            <a:lnRef idx="2">
+              <a:schemeClr val="lt1">
+                <a:hueOff val="0"/>
+                <a:satOff val="0"/>
+                <a:lumOff val="0"/>
+                <a:alphaOff val="0"/>
+              </a:schemeClr>
+            </a:lnRef>
+            <a:fillRef idx="1">
+              <a:schemeClr val="accent1">
+                <a:hueOff val="0"/>
+                <a:satOff val="0"/>
+                <a:lumOff val="0"/>
+                <a:alphaOff val="0"/>
+              </a:schemeClr>
+            </a:fillRef>
+            <a:effectRef idx="0">
+              <a:schemeClr val="accent1">
+                <a:hueOff val="0"/>
+                <a:satOff val="0"/>
+                <a:lumOff val="0"/>
+                <a:alphaOff val="0"/>
+              </a:schemeClr>
+            </a:effectRef>
+            <a:fontRef idx="minor">
+              <a:schemeClr val="lt1"/>
+            </a:fontRef>
+          </p:style>
+          <p:txBody>
+            <a:bodyPr spcFirstLastPara="0" vert="horz" wrap="square" lIns="2992120" tIns="2775373" rIns="499534" bIns="1041401" numCol="1" spcCol="1270" anchor="ctr" anchorCtr="0">
+              <a:noAutofit/>
+            </a:bodyPr>
+            <a:lstStyle/>
+            <a:p>
+              <a:pPr marL="0" lvl="0" indent="0" algn="ctr" defTabSz="2311400">
+                <a:lnSpc>
+                  <a:spcPct val="90000"/>
+                </a:lnSpc>
+                <a:spcBef>
+                  <a:spcPct val="0"/>
+                </a:spcBef>
+                <a:spcAft>
+                  <a:spcPct val="35000"/>
+                </a:spcAft>
+                <a:buNone/>
+              </a:pPr>
+              <a:endParaRPr lang="hu-HU" sz="5200" kern="1200"/>
+            </a:p>
+          </p:txBody>
+        </p:sp>
+        <p:sp>
+          <p:nvSpPr>
+            <p:cNvPr id="8" name="Szabadkézi sokszög: alakzat 7">
+              <a:extLst>
+                <a:ext uri="{FF2B5EF4-FFF2-40B4-BE49-F238E27FC236}">
+                  <a16:creationId xmlns:a16="http://schemas.microsoft.com/office/drawing/2014/main" id="{97651590-CF2A-4AC2-87B7-AE3D3E7EAD54}"/>
+                </a:ext>
+              </a:extLst>
+            </p:cNvPr>
+            <p:cNvSpPr/>
+            <p:nvPr/>
+          </p:nvSpPr>
+          <p:spPr>
+            <a:xfrm>
+              <a:off x="3700664" y="4775512"/>
+              <a:ext cx="1895687" cy="953377"/>
+            </a:xfrm>
+            <a:custGeom>
+              <a:avLst/>
+              <a:gdLst>
+                <a:gd name="connsiteX0" fmla="*/ 1605104 w 1974851"/>
+                <a:gd name="connsiteY0" fmla="*/ 0 h 993190"/>
+                <a:gd name="connsiteX1" fmla="*/ 1974851 w 1974851"/>
+                <a:gd name="connsiteY1" fmla="*/ 767835 h 993190"/>
+                <a:gd name="connsiteX2" fmla="*/ 0 w 1974851"/>
+                <a:gd name="connsiteY2" fmla="*/ 767811 h 993190"/>
+                <a:gd name="connsiteX3" fmla="*/ 364439 w 1974851"/>
+                <a:gd name="connsiteY3" fmla="*/ 11047 h 993190"/>
+                <a:gd name="connsiteX4" fmla="*/ 411025 w 1974851"/>
+                <a:gd name="connsiteY4" fmla="*/ 33489 h 993190"/>
+                <a:gd name="connsiteX5" fmla="*/ 973305 w 1974851"/>
+                <a:gd name="connsiteY5" fmla="*/ 147008 h 993190"/>
+                <a:gd name="connsiteX6" fmla="*/ 1535585 w 1974851"/>
+                <a:gd name="connsiteY6" fmla="*/ 33489 h 993190"/>
+              </a:gdLst>
+              <a:ahLst/>
+              <a:cxnLst>
+                <a:cxn ang="0">
+                  <a:pos x="connsiteX0" y="connsiteY0"/>
+                </a:cxn>
+                <a:cxn ang="0">
+                  <a:pos x="connsiteX1" y="connsiteY1"/>
+                </a:cxn>
+                <a:cxn ang="0">
+                  <a:pos x="connsiteX2" y="connsiteY2"/>
+                </a:cxn>
+                <a:cxn ang="0">
+                  <a:pos x="connsiteX3" y="connsiteY3"/>
+                </a:cxn>
+                <a:cxn ang="0">
+                  <a:pos x="connsiteX4" y="connsiteY4"/>
+                </a:cxn>
+                <a:cxn ang="0">
+                  <a:pos x="connsiteX5" y="connsiteY5"/>
+                </a:cxn>
+                <a:cxn ang="0">
+                  <a:pos x="connsiteX6" y="connsiteY6"/>
+                </a:cxn>
+              </a:cxnLst>
+              <a:rect l="l" t="t" r="r" b="b"/>
+              <a:pathLst>
+                <a:path w="1974851" h="993190">
+                  <a:moveTo>
+                    <a:pt x="1605104" y="0"/>
+                  </a:moveTo>
+                  <a:lnTo>
+                    <a:pt x="1974851" y="767835"/>
+                  </a:lnTo>
+                  <a:cubicBezTo>
+                    <a:pt x="1350855" y="1068317"/>
+                    <a:pt x="623989" y="1068308"/>
+                    <a:pt x="0" y="767811"/>
+                  </a:cubicBezTo>
+                  <a:lnTo>
+                    <a:pt x="364439" y="11047"/>
+                  </a:lnTo>
+                  <a:lnTo>
+                    <a:pt x="411025" y="33489"/>
+                  </a:lnTo>
+                  <a:cubicBezTo>
+                    <a:pt x="583848" y="106587"/>
+                    <a:pt x="773856" y="147008"/>
+                    <a:pt x="973305" y="147008"/>
+                  </a:cubicBezTo>
+                  <a:cubicBezTo>
+                    <a:pt x="1172754" y="147008"/>
+                    <a:pt x="1362763" y="106587"/>
+                    <a:pt x="1535585" y="33489"/>
+                  </a:cubicBezTo>
+                  <a:close/>
+                </a:path>
+              </a:pathLst>
+            </a:custGeom>
+          </p:spPr>
+          <p:style>
+            <a:lnRef idx="2">
+              <a:schemeClr val="lt1">
+                <a:hueOff val="0"/>
+                <a:satOff val="0"/>
+                <a:lumOff val="0"/>
+                <a:alphaOff val="0"/>
+              </a:schemeClr>
+            </a:lnRef>
+            <a:fillRef idx="1">
+              <a:schemeClr val="accent1">
+                <a:hueOff val="0"/>
+                <a:satOff val="0"/>
+                <a:lumOff val="0"/>
+                <a:alphaOff val="0"/>
+              </a:schemeClr>
+            </a:fillRef>
+            <a:effectRef idx="0">
+              <a:schemeClr val="accent1">
+                <a:hueOff val="0"/>
+                <a:satOff val="0"/>
+                <a:lumOff val="0"/>
+                <a:alphaOff val="0"/>
+              </a:schemeClr>
+            </a:effectRef>
+            <a:fontRef idx="minor">
+              <a:schemeClr val="lt1"/>
+            </a:fontRef>
+          </p:style>
+          <p:txBody>
+            <a:bodyPr spcFirstLastPara="0" vert="horz" wrap="square" lIns="1732280" tIns="3642360" rIns="1732280" bIns="174414" numCol="1" spcCol="1270" anchor="ctr" anchorCtr="0">
+              <a:noAutofit/>
+            </a:bodyPr>
+            <a:lstStyle/>
+            <a:p>
+              <a:pPr marL="0" lvl="0" indent="0" algn="ctr" defTabSz="2311400">
+                <a:lnSpc>
+                  <a:spcPct val="90000"/>
+                </a:lnSpc>
+                <a:spcBef>
+                  <a:spcPct val="0"/>
+                </a:spcBef>
+                <a:spcAft>
+                  <a:spcPct val="35000"/>
+                </a:spcAft>
+                <a:buNone/>
+              </a:pPr>
+              <a:endParaRPr lang="hu-HU" sz="5200" kern="1200"/>
+            </a:p>
+          </p:txBody>
+        </p:sp>
+        <p:sp>
+          <p:nvSpPr>
+            <p:cNvPr id="9" name="Szabadkézi sokszög: alakzat 8">
+              <a:extLst>
+                <a:ext uri="{FF2B5EF4-FFF2-40B4-BE49-F238E27FC236}">
+                  <a16:creationId xmlns:a16="http://schemas.microsoft.com/office/drawing/2014/main" id="{37849389-221E-4EA2-9B7B-B721400ABE53}"/>
+                </a:ext>
+              </a:extLst>
+            </p:cNvPr>
+            <p:cNvSpPr/>
+            <p:nvPr/>
+          </p:nvSpPr>
+          <p:spPr>
+            <a:xfrm>
+              <a:off x="2469336" y="3816327"/>
+              <a:ext cx="1531800" cy="1657767"/>
+            </a:xfrm>
+            <a:custGeom>
+              <a:avLst/>
+              <a:gdLst>
+                <a:gd name="connsiteX0" fmla="*/ 801584 w 1595769"/>
+                <a:gd name="connsiteY0" fmla="*/ 0 h 1726996"/>
+                <a:gd name="connsiteX1" fmla="*/ 825038 w 1595769"/>
+                <a:gd name="connsiteY1" fmla="*/ 91215 h 1726996"/>
+                <a:gd name="connsiteX2" fmla="*/ 1516081 w 1595769"/>
+                <a:gd name="connsiteY2" fmla="*/ 931845 h 1726996"/>
+                <a:gd name="connsiteX3" fmla="*/ 1595769 w 1595769"/>
+                <a:gd name="connsiteY3" fmla="*/ 970233 h 1726996"/>
+                <a:gd name="connsiteX4" fmla="*/ 1231330 w 1595769"/>
+                <a:gd name="connsiteY4" fmla="*/ 1726996 h 1726996"/>
+                <a:gd name="connsiteX5" fmla="*/ 0 w 1595769"/>
+                <a:gd name="connsiteY5" fmla="*/ 182956 h 1726996"/>
+              </a:gdLst>
+              <a:ahLst/>
+              <a:cxnLst>
+                <a:cxn ang="0">
+                  <a:pos x="connsiteX0" y="connsiteY0"/>
+                </a:cxn>
+                <a:cxn ang="0">
+                  <a:pos x="connsiteX1" y="connsiteY1"/>
+                </a:cxn>
+                <a:cxn ang="0">
+                  <a:pos x="connsiteX2" y="connsiteY2"/>
+                </a:cxn>
+                <a:cxn ang="0">
+                  <a:pos x="connsiteX3" y="connsiteY3"/>
+                </a:cxn>
+                <a:cxn ang="0">
+                  <a:pos x="connsiteX4" y="connsiteY4"/>
+                </a:cxn>
+                <a:cxn ang="0">
+                  <a:pos x="connsiteX5" y="connsiteY5"/>
+                </a:cxn>
+              </a:cxnLst>
+              <a:rect l="l" t="t" r="r" b="b"/>
+              <a:pathLst>
+                <a:path w="1595769" h="1726996">
+                  <a:moveTo>
+                    <a:pt x="801584" y="0"/>
+                  </a:moveTo>
+                  <a:lnTo>
+                    <a:pt x="825038" y="91215"/>
+                  </a:lnTo>
+                  <a:cubicBezTo>
+                    <a:pt x="937589" y="453078"/>
+                    <a:pt x="1188590" y="753941"/>
+                    <a:pt x="1516081" y="931845"/>
+                  </a:cubicBezTo>
+                  <a:lnTo>
+                    <a:pt x="1595769" y="970233"/>
+                  </a:lnTo>
+                  <a:lnTo>
+                    <a:pt x="1231330" y="1726996"/>
+                  </a:lnTo>
+                  <a:cubicBezTo>
+                    <a:pt x="607324" y="1426490"/>
+                    <a:pt x="154116" y="858186"/>
+                    <a:pt x="0" y="182956"/>
+                  </a:cubicBezTo>
+                  <a:close/>
+                </a:path>
+              </a:pathLst>
+            </a:custGeom>
+          </p:spPr>
+          <p:style>
+            <a:lnRef idx="2">
+              <a:schemeClr val="lt1">
+                <a:hueOff val="0"/>
+                <a:satOff val="0"/>
+                <a:lumOff val="0"/>
+                <a:alphaOff val="0"/>
+              </a:schemeClr>
+            </a:lnRef>
+            <a:fillRef idx="1">
+              <a:schemeClr val="accent1">
+                <a:hueOff val="0"/>
+                <a:satOff val="0"/>
+                <a:lumOff val="0"/>
+                <a:alphaOff val="0"/>
+              </a:schemeClr>
+            </a:fillRef>
+            <a:effectRef idx="0">
+              <a:schemeClr val="accent1">
+                <a:hueOff val="0"/>
+                <a:satOff val="0"/>
+                <a:lumOff val="0"/>
+                <a:alphaOff val="0"/>
+              </a:schemeClr>
+            </a:effectRef>
+            <a:fontRef idx="minor">
+              <a:schemeClr val="lt1"/>
+            </a:fontRef>
+          </p:style>
+          <p:txBody>
+            <a:bodyPr spcFirstLastPara="0" vert="horz" wrap="square" lIns="499533" tIns="2775373" rIns="2992121" bIns="1041401" numCol="1" spcCol="1270" anchor="ctr" anchorCtr="0">
+              <a:noAutofit/>
+            </a:bodyPr>
+            <a:lstStyle/>
+            <a:p>
+              <a:pPr marL="0" lvl="0" indent="0" algn="ctr" defTabSz="2311400">
+                <a:lnSpc>
+                  <a:spcPct val="90000"/>
+                </a:lnSpc>
+                <a:spcBef>
+                  <a:spcPct val="0"/>
+                </a:spcBef>
+                <a:spcAft>
+                  <a:spcPct val="35000"/>
+                </a:spcAft>
+                <a:buNone/>
+              </a:pPr>
+              <a:endParaRPr lang="hu-HU" sz="5200" kern="1200"/>
+            </a:p>
+          </p:txBody>
+        </p:sp>
+        <p:sp>
+          <p:nvSpPr>
+            <p:cNvPr id="10" name="Szabadkézi sokszög: alakzat 9">
+              <a:extLst>
+                <a:ext uri="{FF2B5EF4-FFF2-40B4-BE49-F238E27FC236}">
+                  <a16:creationId xmlns:a16="http://schemas.microsoft.com/office/drawing/2014/main" id="{21DEDC25-CC1E-4639-B92C-F9AC281C2A5D}"/>
+                </a:ext>
+              </a:extLst>
+            </p:cNvPr>
+            <p:cNvSpPr/>
+            <p:nvPr/>
+          </p:nvSpPr>
+          <p:spPr>
+            <a:xfrm>
+              <a:off x="2412256" y="2088414"/>
+              <a:ext cx="1085976" cy="1848201"/>
+            </a:xfrm>
+            <a:custGeom>
+              <a:avLst/>
+              <a:gdLst>
+                <a:gd name="connsiteX0" fmla="*/ 496536 w 1131327"/>
+                <a:gd name="connsiteY0" fmla="*/ 0 h 1925383"/>
+                <a:gd name="connsiteX1" fmla="*/ 1131327 w 1131327"/>
+                <a:gd name="connsiteY1" fmla="*/ 506229 h 1925383"/>
+                <a:gd name="connsiteX2" fmla="*/ 1063879 w 1131327"/>
+                <a:gd name="connsiteY2" fmla="*/ 596425 h 1925383"/>
+                <a:gd name="connsiteX3" fmla="*/ 817174 w 1131327"/>
+                <a:gd name="connsiteY3" fmla="*/ 1404081 h 1925383"/>
+                <a:gd name="connsiteX4" fmla="*/ 846522 w 1131327"/>
+                <a:gd name="connsiteY4" fmla="*/ 1695206 h 1925383"/>
+                <a:gd name="connsiteX5" fmla="*/ 858664 w 1131327"/>
+                <a:gd name="connsiteY5" fmla="*/ 1742428 h 1925383"/>
+                <a:gd name="connsiteX6" fmla="*/ 57080 w 1131327"/>
+                <a:gd name="connsiteY6" fmla="*/ 1925383 h 1925383"/>
+                <a:gd name="connsiteX7" fmla="*/ 496536 w 1131327"/>
+                <a:gd name="connsiteY7" fmla="*/ 0 h 1925383"/>
+              </a:gdLst>
+              <a:ahLst/>
+              <a:cxnLst>
+                <a:cxn ang="0">
+                  <a:pos x="connsiteX0" y="connsiteY0"/>
+                </a:cxn>
+                <a:cxn ang="0">
+                  <a:pos x="connsiteX1" y="connsiteY1"/>
+                </a:cxn>
+                <a:cxn ang="0">
+                  <a:pos x="connsiteX2" y="connsiteY2"/>
+                </a:cxn>
+                <a:cxn ang="0">
+                  <a:pos x="connsiteX3" y="connsiteY3"/>
+                </a:cxn>
+                <a:cxn ang="0">
+                  <a:pos x="connsiteX4" y="connsiteY4"/>
+                </a:cxn>
+                <a:cxn ang="0">
+                  <a:pos x="connsiteX5" y="connsiteY5"/>
+                </a:cxn>
+                <a:cxn ang="0">
+                  <a:pos x="connsiteX6" y="connsiteY6"/>
+                </a:cxn>
+                <a:cxn ang="0">
+                  <a:pos x="connsiteX7" y="connsiteY7"/>
+                </a:cxn>
+              </a:cxnLst>
+              <a:rect l="l" t="t" r="r" b="b"/>
+              <a:pathLst>
+                <a:path w="1131327" h="1925383">
+                  <a:moveTo>
+                    <a:pt x="496536" y="0"/>
+                  </a:moveTo>
+                  <a:lnTo>
+                    <a:pt x="1131327" y="506229"/>
+                  </a:lnTo>
+                  <a:lnTo>
+                    <a:pt x="1063879" y="596425"/>
+                  </a:lnTo>
+                  <a:cubicBezTo>
+                    <a:pt x="908123" y="826975"/>
+                    <a:pt x="817174" y="1104907"/>
+                    <a:pt x="817174" y="1404081"/>
+                  </a:cubicBezTo>
+                  <a:cubicBezTo>
+                    <a:pt x="817174" y="1503806"/>
+                    <a:pt x="827280" y="1601170"/>
+                    <a:pt x="846522" y="1695206"/>
+                  </a:cubicBezTo>
+                  <a:lnTo>
+                    <a:pt x="858664" y="1742428"/>
+                  </a:lnTo>
+                  <a:lnTo>
+                    <a:pt x="57080" y="1925383"/>
+                  </a:lnTo>
+                  <a:cubicBezTo>
+                    <a:pt x="-97036" y="1250154"/>
+                    <a:pt x="64712" y="541492"/>
+                    <a:pt x="496536" y="0"/>
+                  </a:cubicBezTo>
+                  <a:close/>
+                </a:path>
+              </a:pathLst>
+            </a:custGeom>
+          </p:spPr>
+          <p:style>
+            <a:lnRef idx="2">
+              <a:schemeClr val="lt1">
+                <a:hueOff val="0"/>
+                <a:satOff val="0"/>
+                <a:lumOff val="0"/>
+                <a:alphaOff val="0"/>
+              </a:schemeClr>
+            </a:lnRef>
+            <a:fillRef idx="1">
+              <a:schemeClr val="accent1">
+                <a:hueOff val="0"/>
+                <a:satOff val="0"/>
+                <a:lumOff val="0"/>
+                <a:alphaOff val="0"/>
+              </a:schemeClr>
+            </a:fillRef>
+            <a:effectRef idx="0">
+              <a:schemeClr val="accent1">
+                <a:hueOff val="0"/>
+                <a:satOff val="0"/>
+                <a:lumOff val="0"/>
+                <a:alphaOff val="0"/>
+              </a:schemeClr>
+            </a:effectRef>
+            <a:fontRef idx="minor">
+              <a:schemeClr val="lt1"/>
+            </a:fontRef>
+          </p:style>
+          <p:txBody>
+            <a:bodyPr spcFirstLastPara="0" vert="horz" wrap="square" lIns="150622" tIns="1662430" rIns="3152564" bIns="2123017" numCol="1" spcCol="1270" anchor="ctr" anchorCtr="0">
+              <a:noAutofit/>
+            </a:bodyPr>
+            <a:lstStyle/>
+            <a:p>
+              <a:pPr marL="0" lvl="0" indent="0" algn="ctr" defTabSz="1289050">
+                <a:lnSpc>
+                  <a:spcPct val="90000"/>
+                </a:lnSpc>
+                <a:spcBef>
+                  <a:spcPct val="0"/>
+                </a:spcBef>
+                <a:spcAft>
+                  <a:spcPct val="35000"/>
+                </a:spcAft>
+                <a:buNone/>
+              </a:pPr>
+              <a:endParaRPr lang="hu-HU" sz="2900" kern="1200"/>
+            </a:p>
+          </p:txBody>
+        </p:sp>
+        <p:sp>
+          <p:nvSpPr>
+            <p:cNvPr id="11" name="Szabadkézi sokszög: alakzat 10">
+              <a:extLst>
+                <a:ext uri="{FF2B5EF4-FFF2-40B4-BE49-F238E27FC236}">
+                  <a16:creationId xmlns:a16="http://schemas.microsoft.com/office/drawing/2014/main" id="{E5957BF2-A401-4633-946A-7E08130519DF}"/>
+                </a:ext>
+              </a:extLst>
+            </p:cNvPr>
+            <p:cNvSpPr/>
+            <p:nvPr/>
+          </p:nvSpPr>
+          <p:spPr>
+            <a:xfrm>
+              <a:off x="2908790" y="1217022"/>
+              <a:ext cx="1707997" cy="1308464"/>
+            </a:xfrm>
+            <a:custGeom>
+              <a:avLst/>
+              <a:gdLst>
+                <a:gd name="connsiteX0" fmla="*/ 1779324 w 1779324"/>
+                <a:gd name="connsiteY0" fmla="*/ 0 h 1363106"/>
+                <a:gd name="connsiteX1" fmla="*/ 1779324 w 1779324"/>
+                <a:gd name="connsiteY1" fmla="*/ 817132 h 1363106"/>
+                <a:gd name="connsiteX2" fmla="*/ 1765178 w 1779324"/>
+                <a:gd name="connsiteY2" fmla="*/ 816418 h 1363106"/>
+                <a:gd name="connsiteX3" fmla="*/ 650501 w 1779324"/>
+                <a:gd name="connsiteY3" fmla="*/ 1342097 h 1363106"/>
+                <a:gd name="connsiteX4" fmla="*/ 634791 w 1779324"/>
+                <a:gd name="connsiteY4" fmla="*/ 1363106 h 1363106"/>
+                <a:gd name="connsiteX5" fmla="*/ 0 w 1779324"/>
+                <a:gd name="connsiteY5" fmla="*/ 856878 h 1363106"/>
+                <a:gd name="connsiteX6" fmla="*/ 1779324 w 1779324"/>
+                <a:gd name="connsiteY6" fmla="*/ 0 h 1363106"/>
+              </a:gdLst>
+              <a:ahLst/>
+              <a:cxnLst>
+                <a:cxn ang="0">
+                  <a:pos x="connsiteX0" y="connsiteY0"/>
+                </a:cxn>
+                <a:cxn ang="0">
+                  <a:pos x="connsiteX1" y="connsiteY1"/>
+                </a:cxn>
+                <a:cxn ang="0">
+                  <a:pos x="connsiteX2" y="connsiteY2"/>
+                </a:cxn>
+                <a:cxn ang="0">
+                  <a:pos x="connsiteX3" y="connsiteY3"/>
+                </a:cxn>
+                <a:cxn ang="0">
+                  <a:pos x="connsiteX4" y="connsiteY4"/>
+                </a:cxn>
+                <a:cxn ang="0">
+                  <a:pos x="connsiteX5" y="connsiteY5"/>
+                </a:cxn>
+                <a:cxn ang="0">
+                  <a:pos x="connsiteX6" y="connsiteY6"/>
+                </a:cxn>
+              </a:cxnLst>
+              <a:rect l="l" t="t" r="r" b="b"/>
+              <a:pathLst>
+                <a:path w="1779324" h="1363106">
+                  <a:moveTo>
+                    <a:pt x="1779324" y="0"/>
+                  </a:moveTo>
+                  <a:lnTo>
+                    <a:pt x="1779324" y="817132"/>
+                  </a:lnTo>
+                  <a:lnTo>
+                    <a:pt x="1765178" y="816418"/>
+                  </a:lnTo>
+                  <a:cubicBezTo>
+                    <a:pt x="1316417" y="816418"/>
+                    <a:pt x="915451" y="1021052"/>
+                    <a:pt x="650501" y="1342097"/>
+                  </a:cubicBezTo>
+                  <a:lnTo>
+                    <a:pt x="634791" y="1363106"/>
+                  </a:lnTo>
+                  <a:lnTo>
+                    <a:pt x="0" y="856878"/>
+                  </a:lnTo>
+                  <a:cubicBezTo>
+                    <a:pt x="431825" y="315386"/>
+                    <a:pt x="1086729" y="0"/>
+                    <a:pt x="1779324" y="0"/>
+                  </a:cubicBezTo>
+                  <a:close/>
+                </a:path>
+              </a:pathLst>
+            </a:custGeom>
+          </p:spPr>
+          <p:style>
+            <a:lnRef idx="2">
+              <a:schemeClr val="lt1">
+                <a:hueOff val="0"/>
+                <a:satOff val="0"/>
+                <a:lumOff val="0"/>
+                <a:alphaOff val="0"/>
+              </a:schemeClr>
+            </a:lnRef>
+            <a:fillRef idx="1">
+              <a:schemeClr val="accent1">
+                <a:hueOff val="0"/>
+                <a:satOff val="0"/>
+                <a:lumOff val="0"/>
+                <a:alphaOff val="0"/>
+              </a:schemeClr>
+            </a:fillRef>
+            <a:effectRef idx="0">
+              <a:schemeClr val="accent1">
+                <a:hueOff val="0"/>
+                <a:satOff val="0"/>
+                <a:lumOff val="0"/>
+                <a:alphaOff val="0"/>
+              </a:schemeClr>
+            </a:effectRef>
+            <a:fontRef idx="minor">
+              <a:schemeClr val="lt1"/>
+            </a:fontRef>
+          </p:style>
+          <p:txBody>
+            <a:bodyPr spcFirstLastPara="0" vert="horz" wrap="square" lIns="1020487" tIns="467783" rIns="2353480" bIns="3366771" numCol="1" spcCol="1270" anchor="ctr" anchorCtr="0">
+              <a:noAutofit/>
+            </a:bodyPr>
+            <a:lstStyle/>
+            <a:p>
+              <a:pPr marL="0" lvl="0" indent="0" algn="ctr" defTabSz="1200150">
+                <a:lnSpc>
+                  <a:spcPct val="90000"/>
+                </a:lnSpc>
+                <a:spcBef>
+                  <a:spcPct val="0"/>
+                </a:spcBef>
+                <a:spcAft>
+                  <a:spcPct val="35000"/>
+                </a:spcAft>
+                <a:buNone/>
+              </a:pPr>
+              <a:endParaRPr lang="hu-HU" sz="2700" kern="1200"/>
+            </a:p>
+          </p:txBody>
+        </p:sp>
+      </p:grpSp>
     </p:spTree>
     <p:extLst>
       <p:ext uri="{BB962C8B-B14F-4D97-AF65-F5344CB8AC3E}">
@@ -3394,11 +4445,15 @@
     <a:masterClrMapping/>
   </p:clrMapOvr>
   <mc:AlternateContent xmlns:mc="http://schemas.openxmlformats.org/markup-compatibility/2006">
-    <mc:Choice xmlns:p14="http://schemas.microsoft.com/office/powerpoint/2010/main" Requires="p14">
-      <p:transition p14:dur="10"/>
+    <mc:Choice xmlns:p159="http://schemas.microsoft.com/office/powerpoint/2015/09/main" Requires="p159">
+      <p:transition xmlns:p14="http://schemas.microsoft.com/office/powerpoint/2010/main" spd="slow" p14:dur="2000">
+        <p159:morph option="byObject"/>
+      </p:transition>
     </mc:Choice>
     <mc:Fallback>
-      <p:transition/>
+      <p:transition spd="slow">
+        <p:fade/>
+      </p:transition>
     </mc:Fallback>
   </mc:AlternateContent>
 </p:sld>
@@ -3435,7 +4490,7 @@
         </p:nvGrpSpPr>
         <p:grpSpPr>
           <a:xfrm>
-            <a:off x="2412256" y="1217022"/>
+            <a:off x="424109" y="355630"/>
             <a:ext cx="4505659" cy="4511867"/>
             <a:chOff x="2412256" y="1217022"/>
             <a:chExt cx="4505659" cy="4511867"/>
@@ -4433,6 +5488,81 @@
           </p:txBody>
         </p:sp>
       </p:grpSp>
+      <p:sp>
+        <p:nvSpPr>
+          <p:cNvPr id="2" name="Szövegdoboz 1">
+            <a:extLst>
+              <a:ext uri="{FF2B5EF4-FFF2-40B4-BE49-F238E27FC236}">
+                <a16:creationId xmlns:a16="http://schemas.microsoft.com/office/drawing/2014/main" id="{D01C7E67-5737-4ABD-9BEA-6550751B92E3}"/>
+              </a:ext>
+            </a:extLst>
+          </p:cNvPr>
+          <p:cNvSpPr txBox="1"/>
+          <p:nvPr/>
+        </p:nvSpPr>
+        <p:spPr>
+          <a:xfrm>
+            <a:off x="7633252" y="795130"/>
+            <a:ext cx="3763618" cy="1754326"/>
+          </a:xfrm>
+          <a:prstGeom prst="rect">
+            <a:avLst/>
+          </a:prstGeom>
+          <a:noFill/>
+        </p:spPr>
+        <p:txBody>
+          <a:bodyPr wrap="square" rtlCol="0">
+            <a:spAutoFit/>
+          </a:bodyPr>
+          <a:lstStyle/>
+          <a:p>
+            <a:r>
+              <a:rPr lang="hu-HU" dirty="0"/>
+              <a:t>-Bevezetés, gyors talpaló az oldalról</a:t>
+            </a:r>
+          </a:p>
+          <a:p>
+            <a:r>
+              <a:rPr lang="hu-HU" dirty="0"/>
+              <a:t>-cél, </a:t>
+            </a:r>
+          </a:p>
+          <a:p>
+            <a:r>
+              <a:rPr lang="hu-HU" dirty="0"/>
+              <a:t>-adatbázis</a:t>
+            </a:r>
+          </a:p>
+          <a:p>
+            <a:endParaRPr lang="hu-HU" dirty="0"/>
+          </a:p>
+          <a:p>
+            <a:endParaRPr lang="hu-HU" dirty="0"/>
+          </a:p>
+          <a:p>
+            <a:r>
+              <a:rPr lang="hu-HU" dirty="0" err="1"/>
+              <a:t>Dogokét</a:t>
+            </a:r>
+            <a:r>
+              <a:rPr lang="hu-HU"/>
+              <a:t> ellopjuk </a:t>
+            </a:r>
+            <a:r>
+              <a:rPr lang="hu-HU" dirty="0"/>
+              <a:t>(</a:t>
+            </a:r>
+            <a:r>
+              <a:rPr lang="hu-HU" dirty="0" err="1"/>
+              <a:t>github</a:t>
+            </a:r>
+            <a:r>
+              <a:rPr lang="hu-HU" dirty="0"/>
+              <a:t>)</a:t>
+            </a:r>
+          </a:p>
+        </p:txBody>
+      </p:sp>
     </p:spTree>
     <p:extLst>
       <p:ext uri="{BB962C8B-B14F-4D97-AF65-F5344CB8AC3E}">
@@ -4443,6 +5573,18 @@
   <p:clrMapOvr>
     <a:masterClrMapping/>
   </p:clrMapOvr>
+  <mc:AlternateContent xmlns:mc="http://schemas.openxmlformats.org/markup-compatibility/2006">
+    <mc:Choice xmlns:p159="http://schemas.microsoft.com/office/powerpoint/2015/09/main" Requires="p159">
+      <p:transition xmlns:p14="http://schemas.microsoft.com/office/powerpoint/2010/main" spd="slow" p14:dur="2000">
+        <p159:morph option="byObject"/>
+      </p:transition>
+    </mc:Choice>
+    <mc:Fallback>
+      <p:transition spd="slow">
+        <p:fade/>
+      </p:transition>
+    </mc:Fallback>
+  </mc:AlternateContent>
 </p:sld>
 </file>
 

</xml_diff>